<commit_message>
Add & Update ppts
</commit_message>
<xml_diff>
--- a/凱歌.pptx
+++ b/凱歌.pptx
@@ -2,17 +2,17 @@
 <file path=ppt/presentation.xml><?xml version="1.0" encoding="utf-8"?>
 <p:presentation xmlns:a="http://schemas.openxmlformats.org/drawingml/2006/main" xmlns:r="http://schemas.openxmlformats.org/officeDocument/2006/relationships" xmlns:p="http://schemas.openxmlformats.org/presentationml/2006/main" saveSubsetFonts="1">
   <p:sldMasterIdLst>
-    <p:sldMasterId id="2147483660" r:id="rId1"/>
+    <p:sldMasterId id="2147483672" r:id="rId1"/>
   </p:sldMasterIdLst>
   <p:sldIdLst>
     <p:sldId id="256" r:id="rId2"/>
     <p:sldId id="257" r:id="rId3"/>
   </p:sldIdLst>
-  <p:sldSz cx="9144000" cy="6858000" type="screen4x3"/>
+  <p:sldSz cx="12192000" cy="6858000"/>
   <p:notesSz cx="6858000" cy="9144000"/>
   <p:defaultTextStyle>
     <a:defPPr>
-      <a:defRPr lang="en-US"/>
+      <a:defRPr lang="vi-VN"/>
     </a:defPPr>
     <a:lvl1pPr marL="0" algn="l" defTabSz="914400" rtl="0" eaLnBrk="1" latinLnBrk="0" hangingPunct="1">
       <a:defRPr sz="1800" kern="1200">
@@ -105,12 +105,28 @@
       </a:defRPr>
     </a:lvl9pPr>
   </p:defaultTextStyle>
+  <p:extLst>
+    <p:ext uri="{EFAFB233-063F-42B5-8137-9DF3F51BA10A}">
+      <p15:sldGuideLst xmlns:p15="http://schemas.microsoft.com/office/powerpoint/2012/main">
+        <p15:guide id="1" orient="horz" pos="2160" userDrawn="1">
+          <p15:clr>
+            <a:srgbClr val="A4A3A4"/>
+          </p15:clr>
+        </p15:guide>
+        <p15:guide id="2" pos="3840" userDrawn="1">
+          <p15:clr>
+            <a:srgbClr val="A4A3A4"/>
+          </p15:clr>
+        </p15:guide>
+      </p15:sldGuideLst>
+    </p:ext>
+  </p:extLst>
 </p:presentation>
 </file>
 
 <file path=ppt/slideLayouts/slideLayout1.xml><?xml version="1.0" encoding="utf-8"?>
 <p:sldLayout xmlns:a="http://schemas.openxmlformats.org/drawingml/2006/main" xmlns:r="http://schemas.openxmlformats.org/officeDocument/2006/relationships" xmlns:p="http://schemas.openxmlformats.org/presentationml/2006/main" type="title" preserve="1">
-  <p:cSld name="Title Slide">
+  <p:cSld name="標題投影片">
     <p:spTree>
       <p:nvGrpSpPr>
         <p:cNvPr id="1" name=""/>
@@ -127,7 +143,7 @@
       </p:grpSpPr>
       <p:sp>
         <p:nvSpPr>
-          <p:cNvPr id="8" name="Title 7"/>
+          <p:cNvPr id="2" name="標題 1"/>
           <p:cNvSpPr>
             <a:spLocks noGrp="1"/>
           </p:cNvSpPr>
@@ -137,74 +153,144 @@
         </p:nvSpPr>
         <p:spPr>
           <a:xfrm>
-            <a:off x="422030" y="1371600"/>
-            <a:ext cx="8229600" cy="1828800"/>
+            <a:off x="914400" y="2130430"/>
+            <a:ext cx="10363200" cy="1470025"/>
           </a:xfrm>
         </p:spPr>
         <p:txBody>
-          <a:bodyPr vert="horz" lIns="45720" tIns="0" rIns="45720" bIns="0" anchor="b">
-            <a:normAutofit/>
-            <a:scene3d>
-              <a:camera prst="orthographicFront"/>
-              <a:lightRig rig="soft" dir="t">
-                <a:rot lat="0" lon="0" rev="17220000"/>
-              </a:lightRig>
-            </a:scene3d>
-            <a:sp3d prstMaterial="softEdge">
-              <a:bevelT w="38100" h="38100"/>
-            </a:sp3d>
-          </a:bodyPr>
+          <a:bodyPr/>
+          <a:lstStyle/>
+          <a:p>
+            <a:r>
+              <a:rPr lang="en-US" altLang="zh-TW"/>
+              <a:t>Click to edit Master title style</a:t>
+            </a:r>
+            <a:endParaRPr lang="zh-TW" altLang="en-US"/>
+          </a:p>
+        </p:txBody>
+      </p:sp>
+      <p:sp>
+        <p:nvSpPr>
+          <p:cNvPr id="3" name="副標題 2"/>
+          <p:cNvSpPr>
+            <a:spLocks noGrp="1"/>
+          </p:cNvSpPr>
+          <p:nvPr>
+            <p:ph type="subTitle" idx="1"/>
+          </p:nvPr>
+        </p:nvSpPr>
+        <p:spPr>
+          <a:xfrm>
+            <a:off x="1828800" y="3886200"/>
+            <a:ext cx="8534400" cy="1752600"/>
+          </a:xfrm>
+        </p:spPr>
+        <p:txBody>
+          <a:bodyPr/>
           <a:lstStyle>
-            <a:lvl1pPr>
-              <a:defRPr sz="4800" b="1" cap="all" baseline="0">
-                <a:ln w="6350">
-                  <a:noFill/>
-                </a:ln>
-                <a:gradFill>
-                  <a:gsLst>
-                    <a:gs pos="0">
-                      <a:schemeClr val="accent1">
-                        <a:tint val="73000"/>
-                        <a:satMod val="145000"/>
-                      </a:schemeClr>
-                    </a:gs>
-                    <a:gs pos="73000">
-                      <a:schemeClr val="accent1">
-                        <a:tint val="73000"/>
-                        <a:satMod val="145000"/>
-                      </a:schemeClr>
-                    </a:gs>
-                    <a:gs pos="100000">
-                      <a:schemeClr val="accent1">
-                        <a:tint val="83000"/>
-                        <a:satMod val="143000"/>
-                      </a:schemeClr>
-                    </a:gs>
-                  </a:gsLst>
-                  <a:lin ang="4800000" scaled="1"/>
-                </a:gradFill>
-                <a:effectLst>
-                  <a:outerShdw blurRad="127000" dist="200000" dir="2700000" algn="tl" rotWithShape="0">
-                    <a:srgbClr val="000000">
-                      <a:alpha val="30000"/>
-                    </a:srgbClr>
-                  </a:outerShdw>
-                </a:effectLst>
+            <a:lvl1pPr marL="0" indent="0" algn="ctr">
+              <a:buNone/>
+              <a:defRPr>
+                <a:solidFill>
+                  <a:schemeClr val="tx1">
+                    <a:tint val="75000"/>
+                  </a:schemeClr>
+                </a:solidFill>
               </a:defRPr>
             </a:lvl1pPr>
+            <a:lvl2pPr marL="457189" indent="0" algn="ctr">
+              <a:buNone/>
+              <a:defRPr>
+                <a:solidFill>
+                  <a:schemeClr val="tx1">
+                    <a:tint val="75000"/>
+                  </a:schemeClr>
+                </a:solidFill>
+              </a:defRPr>
+            </a:lvl2pPr>
+            <a:lvl3pPr marL="914378" indent="0" algn="ctr">
+              <a:buNone/>
+              <a:defRPr>
+                <a:solidFill>
+                  <a:schemeClr val="tx1">
+                    <a:tint val="75000"/>
+                  </a:schemeClr>
+                </a:solidFill>
+              </a:defRPr>
+            </a:lvl3pPr>
+            <a:lvl4pPr marL="1371566" indent="0" algn="ctr">
+              <a:buNone/>
+              <a:defRPr>
+                <a:solidFill>
+                  <a:schemeClr val="tx1">
+                    <a:tint val="75000"/>
+                  </a:schemeClr>
+                </a:solidFill>
+              </a:defRPr>
+            </a:lvl4pPr>
+            <a:lvl5pPr marL="1828754" indent="0" algn="ctr">
+              <a:buNone/>
+              <a:defRPr>
+                <a:solidFill>
+                  <a:schemeClr val="tx1">
+                    <a:tint val="75000"/>
+                  </a:schemeClr>
+                </a:solidFill>
+              </a:defRPr>
+            </a:lvl5pPr>
+            <a:lvl6pPr marL="2285943" indent="0" algn="ctr">
+              <a:buNone/>
+              <a:defRPr>
+                <a:solidFill>
+                  <a:schemeClr val="tx1">
+                    <a:tint val="75000"/>
+                  </a:schemeClr>
+                </a:solidFill>
+              </a:defRPr>
+            </a:lvl6pPr>
+            <a:lvl7pPr marL="2743132" indent="0" algn="ctr">
+              <a:buNone/>
+              <a:defRPr>
+                <a:solidFill>
+                  <a:schemeClr val="tx1">
+                    <a:tint val="75000"/>
+                  </a:schemeClr>
+                </a:solidFill>
+              </a:defRPr>
+            </a:lvl7pPr>
+            <a:lvl8pPr marL="3200320" indent="0" algn="ctr">
+              <a:buNone/>
+              <a:defRPr>
+                <a:solidFill>
+                  <a:schemeClr val="tx1">
+                    <a:tint val="75000"/>
+                  </a:schemeClr>
+                </a:solidFill>
+              </a:defRPr>
+            </a:lvl8pPr>
+            <a:lvl9pPr marL="3657509" indent="0" algn="ctr">
+              <a:buNone/>
+              <a:defRPr>
+                <a:solidFill>
+                  <a:schemeClr val="tx1">
+                    <a:tint val="75000"/>
+                  </a:schemeClr>
+                </a:solidFill>
+              </a:defRPr>
+            </a:lvl9pPr>
           </a:lstStyle>
           <a:p>
             <a:r>
-              <a:rPr kumimoji="0" lang="en-US" smtClean="0"/>
-              <a:t>Click to edit Master title style</a:t>
-            </a:r>
-            <a:endParaRPr kumimoji="0" lang="en-US"/>
-          </a:p>
-        </p:txBody>
-      </p:sp>
-      <p:sp>
-        <p:nvSpPr>
-          <p:cNvPr id="28" name="Date Placeholder 27"/>
+              <a:rPr lang="en-US" altLang="zh-TW"/>
+              <a:t>Click to edit Master subtitle style</a:t>
+            </a:r>
+            <a:endParaRPr lang="zh-TW" altLang="en-US"/>
+          </a:p>
+        </p:txBody>
+      </p:sp>
+      <p:sp>
+        <p:nvSpPr>
+          <p:cNvPr id="4" name="日期版面配置區 3"/>
           <p:cNvSpPr>
             <a:spLocks noGrp="1"/>
           </p:cNvSpPr>
@@ -219,7 +305,7 @@
           <a:p>
             <a:fld id="{E43ECC0B-00A7-4233-BD1F-1580B09B8357}" type="datetimeFigureOut">
               <a:rPr lang="en-US" smtClean="0"/>
-              <a:t>2/16/2013</a:t>
+              <a:t>6/30/2025</a:t>
             </a:fld>
             <a:endParaRPr lang="en-US"/>
           </a:p>
@@ -227,7 +313,7 @@
       </p:sp>
       <p:sp>
         <p:nvSpPr>
-          <p:cNvPr id="17" name="Footer Placeholder 16"/>
+          <p:cNvPr id="5" name="頁尾版面配置區 4"/>
           <p:cNvSpPr>
             <a:spLocks noGrp="1"/>
           </p:cNvSpPr>
@@ -246,7 +332,7 @@
       </p:sp>
       <p:sp>
         <p:nvSpPr>
-          <p:cNvPr id="29" name="Slide Number Placeholder 28"/>
+          <p:cNvPr id="6" name="投影片編號版面配置區 5"/>
           <p:cNvSpPr>
             <a:spLocks noGrp="1"/>
           </p:cNvSpPr>
@@ -267,68 +353,12 @@
           </a:p>
         </p:txBody>
       </p:sp>
-      <p:sp>
-        <p:nvSpPr>
-          <p:cNvPr id="9" name="Subtitle 8"/>
-          <p:cNvSpPr>
-            <a:spLocks noGrp="1"/>
-          </p:cNvSpPr>
-          <p:nvPr>
-            <p:ph type="subTitle" idx="1"/>
-          </p:nvPr>
-        </p:nvSpPr>
-        <p:spPr>
-          <a:xfrm>
-            <a:off x="1371600" y="3331698"/>
-            <a:ext cx="6400800" cy="1752600"/>
-          </a:xfrm>
-        </p:spPr>
-        <p:txBody>
-          <a:bodyPr/>
-          <a:lstStyle>
-            <a:lvl1pPr marL="0" indent="0" algn="ctr">
-              <a:buNone/>
-              <a:defRPr>
-                <a:solidFill>
-                  <a:schemeClr val="tx1"/>
-                </a:solidFill>
-              </a:defRPr>
-            </a:lvl1pPr>
-            <a:lvl2pPr marL="457200" indent="0" algn="ctr">
-              <a:buNone/>
-            </a:lvl2pPr>
-            <a:lvl3pPr marL="914400" indent="0" algn="ctr">
-              <a:buNone/>
-            </a:lvl3pPr>
-            <a:lvl4pPr marL="1371600" indent="0" algn="ctr">
-              <a:buNone/>
-            </a:lvl4pPr>
-            <a:lvl5pPr marL="1828800" indent="0" algn="ctr">
-              <a:buNone/>
-            </a:lvl5pPr>
-            <a:lvl6pPr marL="2286000" indent="0" algn="ctr">
-              <a:buNone/>
-            </a:lvl6pPr>
-            <a:lvl7pPr marL="2743200" indent="0" algn="ctr">
-              <a:buNone/>
-            </a:lvl7pPr>
-            <a:lvl8pPr marL="3200400" indent="0" algn="ctr">
-              <a:buNone/>
-            </a:lvl8pPr>
-            <a:lvl9pPr marL="3657600" indent="0" algn="ctr">
-              <a:buNone/>
-            </a:lvl9pPr>
-          </a:lstStyle>
-          <a:p>
-            <a:r>
-              <a:rPr kumimoji="0" lang="en-US" smtClean="0"/>
-              <a:t>Click to edit Master subtitle style</a:t>
-            </a:r>
-            <a:endParaRPr kumimoji="0" lang="en-US"/>
-          </a:p>
-        </p:txBody>
-      </p:sp>
     </p:spTree>
+    <p:extLst>
+      <p:ext uri="{BB962C8B-B14F-4D97-AF65-F5344CB8AC3E}">
+        <p14:creationId xmlns:p14="http://schemas.microsoft.com/office/powerpoint/2010/main" val="2195869295"/>
+      </p:ext>
+    </p:extLst>
   </p:cSld>
   <p:clrMapOvr>
     <a:masterClrMapping/>
@@ -338,7 +368,7 @@
 
 <file path=ppt/slideLayouts/slideLayout10.xml><?xml version="1.0" encoding="utf-8"?>
 <p:sldLayout xmlns:a="http://schemas.openxmlformats.org/drawingml/2006/main" xmlns:r="http://schemas.openxmlformats.org/officeDocument/2006/relationships" xmlns:p="http://schemas.openxmlformats.org/presentationml/2006/main" type="vertTx" preserve="1">
-  <p:cSld name="Title and Vertical Text">
+  <p:cSld name="標題及直排文字">
     <p:spTree>
       <p:nvGrpSpPr>
         <p:cNvPr id="1" name=""/>
@@ -355,7 +385,7 @@
       </p:grpSpPr>
       <p:sp>
         <p:nvSpPr>
-          <p:cNvPr id="2" name="Title 1"/>
+          <p:cNvPr id="2" name="標題 1"/>
           <p:cNvSpPr>
             <a:spLocks noGrp="1"/>
           </p:cNvSpPr>
@@ -369,16 +399,16 @@
           <a:lstStyle/>
           <a:p>
             <a:r>
-              <a:rPr kumimoji="0" lang="en-US" smtClean="0"/>
+              <a:rPr lang="en-US" altLang="zh-TW"/>
               <a:t>Click to edit Master title style</a:t>
             </a:r>
-            <a:endParaRPr kumimoji="0" lang="en-US"/>
-          </a:p>
-        </p:txBody>
-      </p:sp>
-      <p:sp>
-        <p:nvSpPr>
-          <p:cNvPr id="3" name="Vertical Text Placeholder 2"/>
+            <a:endParaRPr lang="zh-TW" altLang="en-US"/>
+          </a:p>
+        </p:txBody>
+      </p:sp>
+      <p:sp>
+        <p:nvSpPr>
+          <p:cNvPr id="3" name="直排文字版面配置區 2"/>
           <p:cNvSpPr>
             <a:spLocks noGrp="1"/>
           </p:cNvSpPr>
@@ -391,46 +421,46 @@
           <a:bodyPr vert="eaVert"/>
           <a:lstStyle/>
           <a:p>
-            <a:pPr lvl="0" eaLnBrk="1" latinLnBrk="0" hangingPunct="1"/>
-            <a:r>
-              <a:rPr lang="en-US" smtClean="0"/>
+            <a:pPr lvl="0"/>
+            <a:r>
+              <a:rPr lang="en-US" altLang="zh-TW"/>
               <a:t>Click to edit Master text styles</a:t>
             </a:r>
           </a:p>
           <a:p>
-            <a:pPr lvl="1" eaLnBrk="1" latinLnBrk="0" hangingPunct="1"/>
-            <a:r>
-              <a:rPr lang="en-US" smtClean="0"/>
+            <a:pPr lvl="1"/>
+            <a:r>
+              <a:rPr lang="en-US" altLang="zh-TW"/>
               <a:t>Second level</a:t>
             </a:r>
           </a:p>
           <a:p>
-            <a:pPr lvl="2" eaLnBrk="1" latinLnBrk="0" hangingPunct="1"/>
-            <a:r>
-              <a:rPr lang="en-US" smtClean="0"/>
+            <a:pPr lvl="2"/>
+            <a:r>
+              <a:rPr lang="en-US" altLang="zh-TW"/>
               <a:t>Third level</a:t>
             </a:r>
           </a:p>
           <a:p>
-            <a:pPr lvl="3" eaLnBrk="1" latinLnBrk="0" hangingPunct="1"/>
-            <a:r>
-              <a:rPr lang="en-US" smtClean="0"/>
+            <a:pPr lvl="3"/>
+            <a:r>
+              <a:rPr lang="en-US" altLang="zh-TW"/>
               <a:t>Fourth level</a:t>
             </a:r>
           </a:p>
           <a:p>
-            <a:pPr lvl="4" eaLnBrk="1" latinLnBrk="0" hangingPunct="1"/>
-            <a:r>
-              <a:rPr lang="en-US" smtClean="0"/>
+            <a:pPr lvl="4"/>
+            <a:r>
+              <a:rPr lang="en-US" altLang="zh-TW"/>
               <a:t>Fifth level</a:t>
             </a:r>
-            <a:endParaRPr kumimoji="0" lang="en-US"/>
-          </a:p>
-        </p:txBody>
-      </p:sp>
-      <p:sp>
-        <p:nvSpPr>
-          <p:cNvPr id="4" name="Date Placeholder 3"/>
+            <a:endParaRPr lang="zh-TW" altLang="en-US"/>
+          </a:p>
+        </p:txBody>
+      </p:sp>
+      <p:sp>
+        <p:nvSpPr>
+          <p:cNvPr id="4" name="日期版面配置區 3"/>
           <p:cNvSpPr>
             <a:spLocks noGrp="1"/>
           </p:cNvSpPr>
@@ -445,7 +475,7 @@
           <a:p>
             <a:fld id="{E43ECC0B-00A7-4233-BD1F-1580B09B8357}" type="datetimeFigureOut">
               <a:rPr lang="en-US" smtClean="0"/>
-              <a:t>2/16/2013</a:t>
+              <a:t>6/30/2025</a:t>
             </a:fld>
             <a:endParaRPr lang="en-US"/>
           </a:p>
@@ -453,7 +483,7 @@
       </p:sp>
       <p:sp>
         <p:nvSpPr>
-          <p:cNvPr id="5" name="Footer Placeholder 4"/>
+          <p:cNvPr id="5" name="頁尾版面配置區 4"/>
           <p:cNvSpPr>
             <a:spLocks noGrp="1"/>
           </p:cNvSpPr>
@@ -472,7 +502,7 @@
       </p:sp>
       <p:sp>
         <p:nvSpPr>
-          <p:cNvPr id="6" name="Slide Number Placeholder 5"/>
+          <p:cNvPr id="6" name="投影片編號版面配置區 5"/>
           <p:cNvSpPr>
             <a:spLocks noGrp="1"/>
           </p:cNvSpPr>
@@ -494,6 +524,11 @@
         </p:txBody>
       </p:sp>
     </p:spTree>
+    <p:extLst>
+      <p:ext uri="{BB962C8B-B14F-4D97-AF65-F5344CB8AC3E}">
+        <p14:creationId xmlns:p14="http://schemas.microsoft.com/office/powerpoint/2010/main" val="301136403"/>
+      </p:ext>
+    </p:extLst>
   </p:cSld>
   <p:clrMapOvr>
     <a:masterClrMapping/>
@@ -503,7 +538,7 @@
 
 <file path=ppt/slideLayouts/slideLayout11.xml><?xml version="1.0" encoding="utf-8"?>
 <p:sldLayout xmlns:a="http://schemas.openxmlformats.org/drawingml/2006/main" xmlns:r="http://schemas.openxmlformats.org/officeDocument/2006/relationships" xmlns:p="http://schemas.openxmlformats.org/presentationml/2006/main" type="vertTitleAndTx" preserve="1">
-  <p:cSld name="Vertical Title and Text">
+  <p:cSld name="直排標題及文字">
     <p:spTree>
       <p:nvGrpSpPr>
         <p:cNvPr id="1" name=""/>
@@ -520,7 +555,7 @@
       </p:grpSpPr>
       <p:sp>
         <p:nvSpPr>
-          <p:cNvPr id="2" name="Vertical Title 1"/>
+          <p:cNvPr id="2" name="直排標題 1"/>
           <p:cNvSpPr>
             <a:spLocks noGrp="1"/>
           </p:cNvSpPr>
@@ -530,8 +565,8 @@
         </p:nvSpPr>
         <p:spPr>
           <a:xfrm>
-            <a:off x="6629400" y="274638"/>
-            <a:ext cx="2057400" cy="5851525"/>
+            <a:off x="8839200" y="274641"/>
+            <a:ext cx="2743200" cy="5851525"/>
           </a:xfrm>
         </p:spPr>
         <p:txBody>
@@ -539,16 +574,16 @@
           <a:lstStyle/>
           <a:p>
             <a:r>
-              <a:rPr kumimoji="0" lang="en-US" smtClean="0"/>
+              <a:rPr lang="en-US" altLang="zh-TW"/>
               <a:t>Click to edit Master title style</a:t>
             </a:r>
-            <a:endParaRPr kumimoji="0" lang="en-US"/>
-          </a:p>
-        </p:txBody>
-      </p:sp>
-      <p:sp>
-        <p:nvSpPr>
-          <p:cNvPr id="3" name="Vertical Text Placeholder 2"/>
+            <a:endParaRPr lang="zh-TW" altLang="en-US"/>
+          </a:p>
+        </p:txBody>
+      </p:sp>
+      <p:sp>
+        <p:nvSpPr>
+          <p:cNvPr id="3" name="直排文字版面配置區 2"/>
           <p:cNvSpPr>
             <a:spLocks noGrp="1"/>
           </p:cNvSpPr>
@@ -558,54 +593,54 @@
         </p:nvSpPr>
         <p:spPr>
           <a:xfrm>
-            <a:off x="457200" y="274638"/>
-            <a:ext cx="6019800" cy="5851525"/>
+            <a:off x="609600" y="274641"/>
+            <a:ext cx="8026400" cy="5851525"/>
           </a:xfrm>
         </p:spPr>
         <p:txBody>
           <a:bodyPr vert="eaVert"/>
           <a:lstStyle/>
           <a:p>
-            <a:pPr lvl="0" eaLnBrk="1" latinLnBrk="0" hangingPunct="1"/>
-            <a:r>
-              <a:rPr lang="en-US" smtClean="0"/>
+            <a:pPr lvl="0"/>
+            <a:r>
+              <a:rPr lang="en-US" altLang="zh-TW"/>
               <a:t>Click to edit Master text styles</a:t>
             </a:r>
           </a:p>
           <a:p>
-            <a:pPr lvl="1" eaLnBrk="1" latinLnBrk="0" hangingPunct="1"/>
-            <a:r>
-              <a:rPr lang="en-US" smtClean="0"/>
+            <a:pPr lvl="1"/>
+            <a:r>
+              <a:rPr lang="en-US" altLang="zh-TW"/>
               <a:t>Second level</a:t>
             </a:r>
           </a:p>
           <a:p>
-            <a:pPr lvl="2" eaLnBrk="1" latinLnBrk="0" hangingPunct="1"/>
-            <a:r>
-              <a:rPr lang="en-US" smtClean="0"/>
+            <a:pPr lvl="2"/>
+            <a:r>
+              <a:rPr lang="en-US" altLang="zh-TW"/>
               <a:t>Third level</a:t>
             </a:r>
           </a:p>
           <a:p>
-            <a:pPr lvl="3" eaLnBrk="1" latinLnBrk="0" hangingPunct="1"/>
-            <a:r>
-              <a:rPr lang="en-US" smtClean="0"/>
+            <a:pPr lvl="3"/>
+            <a:r>
+              <a:rPr lang="en-US" altLang="zh-TW"/>
               <a:t>Fourth level</a:t>
             </a:r>
           </a:p>
           <a:p>
-            <a:pPr lvl="4" eaLnBrk="1" latinLnBrk="0" hangingPunct="1"/>
-            <a:r>
-              <a:rPr lang="en-US" smtClean="0"/>
+            <a:pPr lvl="4"/>
+            <a:r>
+              <a:rPr lang="en-US" altLang="zh-TW"/>
               <a:t>Fifth level</a:t>
             </a:r>
-            <a:endParaRPr kumimoji="0" lang="en-US"/>
-          </a:p>
-        </p:txBody>
-      </p:sp>
-      <p:sp>
-        <p:nvSpPr>
-          <p:cNvPr id="4" name="Date Placeholder 3"/>
+            <a:endParaRPr lang="zh-TW" altLang="en-US"/>
+          </a:p>
+        </p:txBody>
+      </p:sp>
+      <p:sp>
+        <p:nvSpPr>
+          <p:cNvPr id="4" name="日期版面配置區 3"/>
           <p:cNvSpPr>
             <a:spLocks noGrp="1"/>
           </p:cNvSpPr>
@@ -620,7 +655,7 @@
           <a:p>
             <a:fld id="{E43ECC0B-00A7-4233-BD1F-1580B09B8357}" type="datetimeFigureOut">
               <a:rPr lang="en-US" smtClean="0"/>
-              <a:t>2/16/2013</a:t>
+              <a:t>6/30/2025</a:t>
             </a:fld>
             <a:endParaRPr lang="en-US"/>
           </a:p>
@@ -628,7 +663,7 @@
       </p:sp>
       <p:sp>
         <p:nvSpPr>
-          <p:cNvPr id="5" name="Footer Placeholder 4"/>
+          <p:cNvPr id="5" name="頁尾版面配置區 4"/>
           <p:cNvSpPr>
             <a:spLocks noGrp="1"/>
           </p:cNvSpPr>
@@ -647,7 +682,7 @@
       </p:sp>
       <p:sp>
         <p:nvSpPr>
-          <p:cNvPr id="6" name="Slide Number Placeholder 5"/>
+          <p:cNvPr id="6" name="投影片編號版面配置區 5"/>
           <p:cNvSpPr>
             <a:spLocks noGrp="1"/>
           </p:cNvSpPr>
@@ -669,6 +704,11 @@
         </p:txBody>
       </p:sp>
     </p:spTree>
+    <p:extLst>
+      <p:ext uri="{BB962C8B-B14F-4D97-AF65-F5344CB8AC3E}">
+        <p14:creationId xmlns:p14="http://schemas.microsoft.com/office/powerpoint/2010/main" val="2657275040"/>
+      </p:ext>
+    </p:extLst>
   </p:cSld>
   <p:clrMapOvr>
     <a:masterClrMapping/>
@@ -678,7 +718,7 @@
 
 <file path=ppt/slideLayouts/slideLayout2.xml><?xml version="1.0" encoding="utf-8"?>
 <p:sldLayout xmlns:a="http://schemas.openxmlformats.org/drawingml/2006/main" xmlns:r="http://schemas.openxmlformats.org/officeDocument/2006/relationships" xmlns:p="http://schemas.openxmlformats.org/presentationml/2006/main" type="obj" preserve="1">
-  <p:cSld name="Title and Content">
+  <p:cSld name="標題及物件">
     <p:spTree>
       <p:nvGrpSpPr>
         <p:cNvPr id="1" name=""/>
@@ -695,7 +735,7 @@
       </p:grpSpPr>
       <p:sp>
         <p:nvSpPr>
-          <p:cNvPr id="2" name="Title 1"/>
+          <p:cNvPr id="2" name="標題 1"/>
           <p:cNvSpPr>
             <a:spLocks noGrp="1"/>
           </p:cNvSpPr>
@@ -709,16 +749,16 @@
           <a:lstStyle/>
           <a:p>
             <a:r>
-              <a:rPr kumimoji="0" lang="en-US" smtClean="0"/>
+              <a:rPr lang="en-US" altLang="zh-TW"/>
               <a:t>Click to edit Master title style</a:t>
             </a:r>
-            <a:endParaRPr kumimoji="0" lang="en-US"/>
-          </a:p>
-        </p:txBody>
-      </p:sp>
-      <p:sp>
-        <p:nvSpPr>
-          <p:cNvPr id="3" name="Content Placeholder 2"/>
+            <a:endParaRPr lang="zh-TW" altLang="en-US"/>
+          </a:p>
+        </p:txBody>
+      </p:sp>
+      <p:sp>
+        <p:nvSpPr>
+          <p:cNvPr id="3" name="內容版面配置區 2"/>
           <p:cNvSpPr>
             <a:spLocks noGrp="1"/>
           </p:cNvSpPr>
@@ -731,46 +771,46 @@
           <a:bodyPr/>
           <a:lstStyle/>
           <a:p>
-            <a:pPr lvl="0" eaLnBrk="1" latinLnBrk="0" hangingPunct="1"/>
-            <a:r>
-              <a:rPr lang="en-US" smtClean="0"/>
+            <a:pPr lvl="0"/>
+            <a:r>
+              <a:rPr lang="en-US" altLang="zh-TW"/>
               <a:t>Click to edit Master text styles</a:t>
             </a:r>
           </a:p>
           <a:p>
-            <a:pPr lvl="1" eaLnBrk="1" latinLnBrk="0" hangingPunct="1"/>
-            <a:r>
-              <a:rPr lang="en-US" smtClean="0"/>
+            <a:pPr lvl="1"/>
+            <a:r>
+              <a:rPr lang="en-US" altLang="zh-TW"/>
               <a:t>Second level</a:t>
             </a:r>
           </a:p>
           <a:p>
-            <a:pPr lvl="2" eaLnBrk="1" latinLnBrk="0" hangingPunct="1"/>
-            <a:r>
-              <a:rPr lang="en-US" smtClean="0"/>
+            <a:pPr lvl="2"/>
+            <a:r>
+              <a:rPr lang="en-US" altLang="zh-TW"/>
               <a:t>Third level</a:t>
             </a:r>
           </a:p>
           <a:p>
-            <a:pPr lvl="3" eaLnBrk="1" latinLnBrk="0" hangingPunct="1"/>
-            <a:r>
-              <a:rPr lang="en-US" smtClean="0"/>
+            <a:pPr lvl="3"/>
+            <a:r>
+              <a:rPr lang="en-US" altLang="zh-TW"/>
               <a:t>Fourth level</a:t>
             </a:r>
           </a:p>
           <a:p>
-            <a:pPr lvl="4" eaLnBrk="1" latinLnBrk="0" hangingPunct="1"/>
-            <a:r>
-              <a:rPr lang="en-US" smtClean="0"/>
+            <a:pPr lvl="4"/>
+            <a:r>
+              <a:rPr lang="en-US" altLang="zh-TW"/>
               <a:t>Fifth level</a:t>
             </a:r>
-            <a:endParaRPr kumimoji="0" lang="en-US"/>
-          </a:p>
-        </p:txBody>
-      </p:sp>
-      <p:sp>
-        <p:nvSpPr>
-          <p:cNvPr id="4" name="Date Placeholder 3"/>
+            <a:endParaRPr lang="zh-TW" altLang="en-US"/>
+          </a:p>
+        </p:txBody>
+      </p:sp>
+      <p:sp>
+        <p:nvSpPr>
+          <p:cNvPr id="4" name="日期版面配置區 3"/>
           <p:cNvSpPr>
             <a:spLocks noGrp="1"/>
           </p:cNvSpPr>
@@ -785,7 +825,7 @@
           <a:p>
             <a:fld id="{E43ECC0B-00A7-4233-BD1F-1580B09B8357}" type="datetimeFigureOut">
               <a:rPr lang="en-US" smtClean="0"/>
-              <a:t>2/16/2013</a:t>
+              <a:t>6/30/2025</a:t>
             </a:fld>
             <a:endParaRPr lang="en-US"/>
           </a:p>
@@ -793,7 +833,7 @@
       </p:sp>
       <p:sp>
         <p:nvSpPr>
-          <p:cNvPr id="5" name="Footer Placeholder 4"/>
+          <p:cNvPr id="5" name="頁尾版面配置區 4"/>
           <p:cNvSpPr>
             <a:spLocks noGrp="1"/>
           </p:cNvSpPr>
@@ -812,7 +852,7 @@
       </p:sp>
       <p:sp>
         <p:nvSpPr>
-          <p:cNvPr id="6" name="Slide Number Placeholder 5"/>
+          <p:cNvPr id="6" name="投影片編號版面配置區 5"/>
           <p:cNvSpPr>
             <a:spLocks noGrp="1"/>
           </p:cNvSpPr>
@@ -834,6 +874,11 @@
         </p:txBody>
       </p:sp>
     </p:spTree>
+    <p:extLst>
+      <p:ext uri="{BB962C8B-B14F-4D97-AF65-F5344CB8AC3E}">
+        <p14:creationId xmlns:p14="http://schemas.microsoft.com/office/powerpoint/2010/main" val="4057534371"/>
+      </p:ext>
+    </p:extLst>
   </p:cSld>
   <p:clrMapOvr>
     <a:masterClrMapping/>
@@ -843,12 +888,7 @@
 
 <file path=ppt/slideLayouts/slideLayout3.xml><?xml version="1.0" encoding="utf-8"?>
 <p:sldLayout xmlns:a="http://schemas.openxmlformats.org/drawingml/2006/main" xmlns:r="http://schemas.openxmlformats.org/officeDocument/2006/relationships" xmlns:p="http://schemas.openxmlformats.org/presentationml/2006/main" type="secHead" preserve="1">
-  <p:cSld name="Section Header">
-    <p:bg>
-      <p:bgRef idx="1003">
-        <a:schemeClr val="bg2"/>
-      </p:bgRef>
-    </p:bg>
+  <p:cSld name="區段標題">
     <p:spTree>
       <p:nvGrpSpPr>
         <p:cNvPr id="1" name=""/>
@@ -865,7 +905,7 @@
       </p:grpSpPr>
       <p:sp>
         <p:nvSpPr>
-          <p:cNvPr id="2" name="Title 1"/>
+          <p:cNvPr id="2" name="標題 1"/>
           <p:cNvSpPr>
             <a:spLocks noGrp="1"/>
           </p:cNvSpPr>
@@ -875,69 +915,29 @@
         </p:nvSpPr>
         <p:spPr>
           <a:xfrm>
-            <a:off x="1600200" y="609600"/>
-            <a:ext cx="7086600" cy="1828800"/>
+            <a:off x="963084" y="4406903"/>
+            <a:ext cx="10363200" cy="1362075"/>
           </a:xfrm>
         </p:spPr>
         <p:txBody>
-          <a:bodyPr vert="horz" bIns="0" anchor="b">
-            <a:noAutofit/>
-            <a:scene3d>
-              <a:camera prst="orthographicFront"/>
-              <a:lightRig rig="soft" dir="t">
-                <a:rot lat="0" lon="0" rev="17220000"/>
-              </a:lightRig>
-            </a:scene3d>
-            <a:sp3d prstMaterial="softEdge">
-              <a:bevelT w="38100" h="38100"/>
-              <a:contourClr>
-                <a:schemeClr val="tx2">
-                  <a:shade val="50000"/>
-                </a:schemeClr>
-              </a:contourClr>
-            </a:sp3d>
-          </a:bodyPr>
+          <a:bodyPr anchor="t"/>
           <a:lstStyle>
-            <a:lvl1pPr algn="l" rtl="0">
-              <a:spcBef>
-                <a:spcPct val="0"/>
-              </a:spcBef>
-              <a:buNone/>
-              <a:defRPr sz="4800" b="1" cap="none" baseline="0">
-                <a:ln w="6350">
-                  <a:noFill/>
-                </a:ln>
-                <a:solidFill>
-                  <a:schemeClr val="accent1">
-                    <a:tint val="90000"/>
-                    <a:satMod val="120000"/>
-                  </a:schemeClr>
-                </a:solidFill>
-                <a:effectLst>
-                  <a:outerShdw blurRad="114300" dist="101600" dir="2700000" algn="tl" rotWithShape="0">
-                    <a:srgbClr val="000000">
-                      <a:alpha val="40000"/>
-                    </a:srgbClr>
-                  </a:outerShdw>
-                </a:effectLst>
-                <a:latin typeface="+mj-lt"/>
-                <a:ea typeface="+mj-ea"/>
-                <a:cs typeface="+mj-cs"/>
-              </a:defRPr>
+            <a:lvl1pPr algn="l">
+              <a:defRPr sz="4000" b="1" cap="all"/>
             </a:lvl1pPr>
           </a:lstStyle>
           <a:p>
             <a:r>
-              <a:rPr kumimoji="0" lang="en-US" smtClean="0"/>
+              <a:rPr lang="en-US" altLang="zh-TW"/>
               <a:t>Click to edit Master title style</a:t>
             </a:r>
-            <a:endParaRPr kumimoji="0" lang="en-US"/>
-          </a:p>
-        </p:txBody>
-      </p:sp>
-      <p:sp>
-        <p:nvSpPr>
-          <p:cNvPr id="3" name="Text Placeholder 2"/>
+            <a:endParaRPr lang="zh-TW" altLang="en-US"/>
+          </a:p>
+        </p:txBody>
+      </p:sp>
+      <p:sp>
+        <p:nvSpPr>
+          <p:cNvPr id="3" name="文字版面配置區 2"/>
           <p:cNvSpPr>
             <a:spLocks noGrp="1"/>
           </p:cNvSpPr>
@@ -947,22 +947,24 @@
         </p:nvSpPr>
         <p:spPr>
           <a:xfrm>
-            <a:off x="1600200" y="2507786"/>
-            <a:ext cx="7086600" cy="1509712"/>
+            <a:off x="963084" y="2906713"/>
+            <a:ext cx="10363200" cy="1500187"/>
           </a:xfrm>
         </p:spPr>
         <p:txBody>
-          <a:bodyPr anchor="t"/>
+          <a:bodyPr anchor="b"/>
           <a:lstStyle>
-            <a:lvl1pPr marL="73152" indent="0" algn="l">
+            <a:lvl1pPr marL="0" indent="0">
               <a:buNone/>
               <a:defRPr sz="2000">
                 <a:solidFill>
-                  <a:schemeClr val="tx1"/>
+                  <a:schemeClr val="tx1">
+                    <a:tint val="75000"/>
+                  </a:schemeClr>
                 </a:solidFill>
               </a:defRPr>
             </a:lvl1pPr>
-            <a:lvl2pPr>
+            <a:lvl2pPr marL="457189" indent="0">
               <a:buNone/>
               <a:defRPr sz="1800">
                 <a:solidFill>
@@ -972,7 +974,7 @@
                 </a:solidFill>
               </a:defRPr>
             </a:lvl2pPr>
-            <a:lvl3pPr>
+            <a:lvl3pPr marL="914378" indent="0">
               <a:buNone/>
               <a:defRPr sz="1600">
                 <a:solidFill>
@@ -982,7 +984,7 @@
                 </a:solidFill>
               </a:defRPr>
             </a:lvl3pPr>
-            <a:lvl4pPr>
+            <a:lvl4pPr marL="1371566" indent="0">
               <a:buNone/>
               <a:defRPr sz="1400">
                 <a:solidFill>
@@ -992,7 +994,7 @@
                 </a:solidFill>
               </a:defRPr>
             </a:lvl4pPr>
-            <a:lvl5pPr>
+            <a:lvl5pPr marL="1828754" indent="0">
               <a:buNone/>
               <a:defRPr sz="1400">
                 <a:solidFill>
@@ -1002,11 +1004,51 @@
                 </a:solidFill>
               </a:defRPr>
             </a:lvl5pPr>
+            <a:lvl6pPr marL="2285943" indent="0">
+              <a:buNone/>
+              <a:defRPr sz="1400">
+                <a:solidFill>
+                  <a:schemeClr val="tx1">
+                    <a:tint val="75000"/>
+                  </a:schemeClr>
+                </a:solidFill>
+              </a:defRPr>
+            </a:lvl6pPr>
+            <a:lvl7pPr marL="2743132" indent="0">
+              <a:buNone/>
+              <a:defRPr sz="1400">
+                <a:solidFill>
+                  <a:schemeClr val="tx1">
+                    <a:tint val="75000"/>
+                  </a:schemeClr>
+                </a:solidFill>
+              </a:defRPr>
+            </a:lvl7pPr>
+            <a:lvl8pPr marL="3200320" indent="0">
+              <a:buNone/>
+              <a:defRPr sz="1400">
+                <a:solidFill>
+                  <a:schemeClr val="tx1">
+                    <a:tint val="75000"/>
+                  </a:schemeClr>
+                </a:solidFill>
+              </a:defRPr>
+            </a:lvl8pPr>
+            <a:lvl9pPr marL="3657509" indent="0">
+              <a:buNone/>
+              <a:defRPr sz="1400">
+                <a:solidFill>
+                  <a:schemeClr val="tx1">
+                    <a:tint val="75000"/>
+                  </a:schemeClr>
+                </a:solidFill>
+              </a:defRPr>
+            </a:lvl9pPr>
           </a:lstStyle>
           <a:p>
-            <a:pPr lvl="0" eaLnBrk="1" latinLnBrk="0" hangingPunct="1"/>
-            <a:r>
-              <a:rPr kumimoji="0" lang="en-US" smtClean="0"/>
+            <a:pPr lvl="0"/>
+            <a:r>
+              <a:rPr lang="en-US" altLang="zh-TW"/>
               <a:t>Click to edit Master text styles</a:t>
             </a:r>
           </a:p>
@@ -1014,7 +1056,7 @@
       </p:sp>
       <p:sp>
         <p:nvSpPr>
-          <p:cNvPr id="4" name="Date Placeholder 3"/>
+          <p:cNvPr id="4" name="日期版面配置區 3"/>
           <p:cNvSpPr>
             <a:spLocks noGrp="1"/>
           </p:cNvSpPr>
@@ -1029,7 +1071,7 @@
           <a:p>
             <a:fld id="{E43ECC0B-00A7-4233-BD1F-1580B09B8357}" type="datetimeFigureOut">
               <a:rPr lang="en-US" smtClean="0"/>
-              <a:t>2/16/2013</a:t>
+              <a:t>6/30/2025</a:t>
             </a:fld>
             <a:endParaRPr lang="en-US"/>
           </a:p>
@@ -1037,7 +1079,7 @@
       </p:sp>
       <p:sp>
         <p:nvSpPr>
-          <p:cNvPr id="5" name="Footer Placeholder 4"/>
+          <p:cNvPr id="5" name="頁尾版面配置區 4"/>
           <p:cNvSpPr>
             <a:spLocks noGrp="1"/>
           </p:cNvSpPr>
@@ -1056,7 +1098,7 @@
       </p:sp>
       <p:sp>
         <p:nvSpPr>
-          <p:cNvPr id="6" name="Slide Number Placeholder 5"/>
+          <p:cNvPr id="6" name="投影片編號版面配置區 5"/>
           <p:cNvSpPr>
             <a:spLocks noGrp="1"/>
           </p:cNvSpPr>
@@ -1064,12 +1106,7 @@
             <p:ph type="sldNum" sz="quarter" idx="12"/>
           </p:nvPr>
         </p:nvSpPr>
-        <p:spPr>
-          <a:xfrm>
-            <a:off x="7924800" y="6416675"/>
-            <a:ext cx="762000" cy="365125"/>
-          </a:xfrm>
-        </p:spPr>
+        <p:spPr/>
         <p:txBody>
           <a:bodyPr/>
           <a:lstStyle/>
@@ -1083,16 +1120,21 @@
         </p:txBody>
       </p:sp>
     </p:spTree>
+    <p:extLst>
+      <p:ext uri="{BB962C8B-B14F-4D97-AF65-F5344CB8AC3E}">
+        <p14:creationId xmlns:p14="http://schemas.microsoft.com/office/powerpoint/2010/main" val="3474536918"/>
+      </p:ext>
+    </p:extLst>
   </p:cSld>
   <p:clrMapOvr>
-    <a:overrideClrMapping bg1="dk1" tx1="lt1" bg2="dk2" tx2="lt2" accent1="accent1" accent2="accent2" accent3="accent3" accent4="accent4" accent5="accent5" accent6="accent6" hlink="hlink" folHlink="folHlink"/>
+    <a:masterClrMapping/>
   </p:clrMapOvr>
 </p:sldLayout>
 </file>
 
 <file path=ppt/slideLayouts/slideLayout4.xml><?xml version="1.0" encoding="utf-8"?>
 <p:sldLayout xmlns:a="http://schemas.openxmlformats.org/drawingml/2006/main" xmlns:r="http://schemas.openxmlformats.org/officeDocument/2006/relationships" xmlns:p="http://schemas.openxmlformats.org/presentationml/2006/main" type="twoObj" preserve="1">
-  <p:cSld name="Two Content">
+  <p:cSld name="兩項物件">
     <p:spTree>
       <p:nvGrpSpPr>
         <p:cNvPr id="1" name=""/>
@@ -1109,7 +1151,7 @@
       </p:grpSpPr>
       <p:sp>
         <p:nvSpPr>
-          <p:cNvPr id="2" name="Title 1"/>
+          <p:cNvPr id="2" name="標題 1"/>
           <p:cNvSpPr>
             <a:spLocks noGrp="1"/>
           </p:cNvSpPr>
@@ -1123,16 +1165,16 @@
           <a:lstStyle/>
           <a:p>
             <a:r>
-              <a:rPr kumimoji="0" lang="en-US" smtClean="0"/>
+              <a:rPr lang="en-US" altLang="zh-TW"/>
               <a:t>Click to edit Master title style</a:t>
             </a:r>
-            <a:endParaRPr kumimoji="0" lang="en-US"/>
-          </a:p>
-        </p:txBody>
-      </p:sp>
-      <p:sp>
-        <p:nvSpPr>
-          <p:cNvPr id="3" name="Content Placeholder 2"/>
+            <a:endParaRPr lang="zh-TW" altLang="en-US"/>
+          </a:p>
+        </p:txBody>
+      </p:sp>
+      <p:sp>
+        <p:nvSpPr>
+          <p:cNvPr id="3" name="內容版面配置區 2"/>
           <p:cNvSpPr>
             <a:spLocks noGrp="1"/>
           </p:cNvSpPr>
@@ -1142,15 +1184,15 @@
         </p:nvSpPr>
         <p:spPr>
           <a:xfrm>
-            <a:off x="457200" y="1600200"/>
-            <a:ext cx="4038600" cy="4525963"/>
+            <a:off x="609600" y="1600203"/>
+            <a:ext cx="5384800" cy="4525963"/>
           </a:xfrm>
         </p:spPr>
         <p:txBody>
           <a:bodyPr/>
           <a:lstStyle>
             <a:lvl1pPr>
-              <a:defRPr sz="2600"/>
+              <a:defRPr sz="2800"/>
             </a:lvl1pPr>
             <a:lvl2pPr>
               <a:defRPr sz="2400"/>
@@ -1164,48 +1206,60 @@
             <a:lvl5pPr>
               <a:defRPr sz="1800"/>
             </a:lvl5pPr>
+            <a:lvl6pPr>
+              <a:defRPr sz="1800"/>
+            </a:lvl6pPr>
+            <a:lvl7pPr>
+              <a:defRPr sz="1800"/>
+            </a:lvl7pPr>
+            <a:lvl8pPr>
+              <a:defRPr sz="1800"/>
+            </a:lvl8pPr>
+            <a:lvl9pPr>
+              <a:defRPr sz="1800"/>
+            </a:lvl9pPr>
           </a:lstStyle>
           <a:p>
-            <a:pPr lvl="0" eaLnBrk="1" latinLnBrk="0" hangingPunct="1"/>
-            <a:r>
-              <a:rPr lang="en-US" smtClean="0"/>
+            <a:pPr lvl="0"/>
+            <a:r>
+              <a:rPr lang="en-US" altLang="zh-TW"/>
               <a:t>Click to edit Master text styles</a:t>
             </a:r>
           </a:p>
           <a:p>
-            <a:pPr lvl="1" eaLnBrk="1" latinLnBrk="0" hangingPunct="1"/>
-            <a:r>
-              <a:rPr lang="en-US" smtClean="0"/>
+            <a:pPr lvl="1"/>
+            <a:r>
+              <a:rPr lang="en-US" altLang="zh-TW"/>
               <a:t>Second level</a:t>
             </a:r>
           </a:p>
           <a:p>
-            <a:pPr lvl="2" eaLnBrk="1" latinLnBrk="0" hangingPunct="1"/>
-            <a:r>
-              <a:rPr lang="en-US" smtClean="0"/>
+            <a:pPr lvl="2"/>
+            <a:r>
+              <a:rPr lang="en-US" altLang="zh-TW"/>
               <a:t>Third level</a:t>
             </a:r>
           </a:p>
           <a:p>
-            <a:pPr lvl="3" eaLnBrk="1" latinLnBrk="0" hangingPunct="1"/>
-            <a:r>
-              <a:rPr lang="en-US" smtClean="0"/>
+            <a:pPr lvl="3"/>
+            <a:r>
+              <a:rPr lang="en-US" altLang="zh-TW"/>
               <a:t>Fourth level</a:t>
             </a:r>
           </a:p>
           <a:p>
-            <a:pPr lvl="4" eaLnBrk="1" latinLnBrk="0" hangingPunct="1"/>
-            <a:r>
-              <a:rPr lang="en-US" smtClean="0"/>
+            <a:pPr lvl="4"/>
+            <a:r>
+              <a:rPr lang="en-US" altLang="zh-TW"/>
               <a:t>Fifth level</a:t>
             </a:r>
-            <a:endParaRPr kumimoji="0" lang="en-US"/>
-          </a:p>
-        </p:txBody>
-      </p:sp>
-      <p:sp>
-        <p:nvSpPr>
-          <p:cNvPr id="4" name="Content Placeholder 3"/>
+            <a:endParaRPr lang="zh-TW" altLang="en-US"/>
+          </a:p>
+        </p:txBody>
+      </p:sp>
+      <p:sp>
+        <p:nvSpPr>
+          <p:cNvPr id="4" name="內容版面配置區 3"/>
           <p:cNvSpPr>
             <a:spLocks noGrp="1"/>
           </p:cNvSpPr>
@@ -1215,15 +1269,15 @@
         </p:nvSpPr>
         <p:spPr>
           <a:xfrm>
-            <a:off x="4648200" y="1600200"/>
-            <a:ext cx="4038600" cy="4525963"/>
+            <a:off x="6197600" y="1600203"/>
+            <a:ext cx="5384800" cy="4525963"/>
           </a:xfrm>
         </p:spPr>
         <p:txBody>
           <a:bodyPr/>
           <a:lstStyle>
             <a:lvl1pPr>
-              <a:defRPr sz="2600"/>
+              <a:defRPr sz="2800"/>
             </a:lvl1pPr>
             <a:lvl2pPr>
               <a:defRPr sz="2400"/>
@@ -1237,48 +1291,60 @@
             <a:lvl5pPr>
               <a:defRPr sz="1800"/>
             </a:lvl5pPr>
+            <a:lvl6pPr>
+              <a:defRPr sz="1800"/>
+            </a:lvl6pPr>
+            <a:lvl7pPr>
+              <a:defRPr sz="1800"/>
+            </a:lvl7pPr>
+            <a:lvl8pPr>
+              <a:defRPr sz="1800"/>
+            </a:lvl8pPr>
+            <a:lvl9pPr>
+              <a:defRPr sz="1800"/>
+            </a:lvl9pPr>
           </a:lstStyle>
           <a:p>
-            <a:pPr lvl="0" eaLnBrk="1" latinLnBrk="0" hangingPunct="1"/>
-            <a:r>
-              <a:rPr lang="en-US" smtClean="0"/>
+            <a:pPr lvl="0"/>
+            <a:r>
+              <a:rPr lang="en-US" altLang="zh-TW"/>
               <a:t>Click to edit Master text styles</a:t>
             </a:r>
           </a:p>
           <a:p>
-            <a:pPr lvl="1" eaLnBrk="1" latinLnBrk="0" hangingPunct="1"/>
-            <a:r>
-              <a:rPr lang="en-US" smtClean="0"/>
+            <a:pPr lvl="1"/>
+            <a:r>
+              <a:rPr lang="en-US" altLang="zh-TW"/>
               <a:t>Second level</a:t>
             </a:r>
           </a:p>
           <a:p>
-            <a:pPr lvl="2" eaLnBrk="1" latinLnBrk="0" hangingPunct="1"/>
-            <a:r>
-              <a:rPr lang="en-US" smtClean="0"/>
+            <a:pPr lvl="2"/>
+            <a:r>
+              <a:rPr lang="en-US" altLang="zh-TW"/>
               <a:t>Third level</a:t>
             </a:r>
           </a:p>
           <a:p>
-            <a:pPr lvl="3" eaLnBrk="1" latinLnBrk="0" hangingPunct="1"/>
-            <a:r>
-              <a:rPr lang="en-US" smtClean="0"/>
+            <a:pPr lvl="3"/>
+            <a:r>
+              <a:rPr lang="en-US" altLang="zh-TW"/>
               <a:t>Fourth level</a:t>
             </a:r>
           </a:p>
           <a:p>
-            <a:pPr lvl="4" eaLnBrk="1" latinLnBrk="0" hangingPunct="1"/>
-            <a:r>
-              <a:rPr lang="en-US" smtClean="0"/>
+            <a:pPr lvl="4"/>
+            <a:r>
+              <a:rPr lang="en-US" altLang="zh-TW"/>
               <a:t>Fifth level</a:t>
             </a:r>
-            <a:endParaRPr kumimoji="0" lang="en-US"/>
-          </a:p>
-        </p:txBody>
-      </p:sp>
-      <p:sp>
-        <p:nvSpPr>
-          <p:cNvPr id="5" name="Date Placeholder 4"/>
+            <a:endParaRPr lang="zh-TW" altLang="en-US"/>
+          </a:p>
+        </p:txBody>
+      </p:sp>
+      <p:sp>
+        <p:nvSpPr>
+          <p:cNvPr id="5" name="日期版面配置區 4"/>
           <p:cNvSpPr>
             <a:spLocks noGrp="1"/>
           </p:cNvSpPr>
@@ -1293,7 +1359,7 @@
           <a:p>
             <a:fld id="{E43ECC0B-00A7-4233-BD1F-1580B09B8357}" type="datetimeFigureOut">
               <a:rPr lang="en-US" smtClean="0"/>
-              <a:t>2/16/2013</a:t>
+              <a:t>6/30/2025</a:t>
             </a:fld>
             <a:endParaRPr lang="en-US"/>
           </a:p>
@@ -1301,7 +1367,7 @@
       </p:sp>
       <p:sp>
         <p:nvSpPr>
-          <p:cNvPr id="6" name="Footer Placeholder 5"/>
+          <p:cNvPr id="6" name="頁尾版面配置區 5"/>
           <p:cNvSpPr>
             <a:spLocks noGrp="1"/>
           </p:cNvSpPr>
@@ -1320,7 +1386,7 @@
       </p:sp>
       <p:sp>
         <p:nvSpPr>
-          <p:cNvPr id="7" name="Slide Number Placeholder 6"/>
+          <p:cNvPr id="7" name="投影片編號版面配置區 6"/>
           <p:cNvSpPr>
             <a:spLocks noGrp="1"/>
           </p:cNvSpPr>
@@ -1342,6 +1408,11 @@
         </p:txBody>
       </p:sp>
     </p:spTree>
+    <p:extLst>
+      <p:ext uri="{BB962C8B-B14F-4D97-AF65-F5344CB8AC3E}">
+        <p14:creationId xmlns:p14="http://schemas.microsoft.com/office/powerpoint/2010/main" val="3650319235"/>
+      </p:ext>
+    </p:extLst>
   </p:cSld>
   <p:clrMapOvr>
     <a:masterClrMapping/>
@@ -1351,7 +1422,7 @@
 
 <file path=ppt/slideLayouts/slideLayout5.xml><?xml version="1.0" encoding="utf-8"?>
 <p:sldLayout xmlns:a="http://schemas.openxmlformats.org/drawingml/2006/main" xmlns:r="http://schemas.openxmlformats.org/officeDocument/2006/relationships" xmlns:p="http://schemas.openxmlformats.org/presentationml/2006/main" type="twoTxTwoObj" preserve="1">
-  <p:cSld name="Comparison">
+  <p:cSld name="比對">
     <p:spTree>
       <p:nvGrpSpPr>
         <p:cNvPr id="1" name=""/>
@@ -1368,7 +1439,7 @@
       </p:grpSpPr>
       <p:sp>
         <p:nvSpPr>
-          <p:cNvPr id="2" name="Title 1"/>
+          <p:cNvPr id="2" name="標題 1"/>
           <p:cNvSpPr>
             <a:spLocks noGrp="1"/>
           </p:cNvSpPr>
@@ -1376,14 +1447,9 @@
             <p:ph type="title"/>
           </p:nvPr>
         </p:nvSpPr>
-        <p:spPr>
-          <a:xfrm>
-            <a:off x="457200" y="273050"/>
-            <a:ext cx="8229600" cy="1143000"/>
-          </a:xfrm>
-        </p:spPr>
-        <p:txBody>
-          <a:bodyPr anchor="ctr"/>
+        <p:spPr/>
+        <p:txBody>
+          <a:bodyPr/>
           <a:lstStyle>
             <a:lvl1pPr>
               <a:defRPr/>
@@ -1391,16 +1457,16 @@
           </a:lstStyle>
           <a:p>
             <a:r>
-              <a:rPr kumimoji="0" lang="en-US" smtClean="0"/>
+              <a:rPr lang="en-US" altLang="zh-TW"/>
               <a:t>Click to edit Master title style</a:t>
             </a:r>
-            <a:endParaRPr kumimoji="0" lang="en-US"/>
-          </a:p>
-        </p:txBody>
-      </p:sp>
-      <p:sp>
-        <p:nvSpPr>
-          <p:cNvPr id="3" name="Text Placeholder 2"/>
+            <a:endParaRPr lang="zh-TW" altLang="en-US"/>
+          </a:p>
+        </p:txBody>
+      </p:sp>
+      <p:sp>
+        <p:nvSpPr>
+          <p:cNvPr id="3" name="文字版面配置區 2"/>
           <p:cNvSpPr>
             <a:spLocks noGrp="1"/>
           </p:cNvSpPr>
@@ -1410,42 +1476,54 @@
         </p:nvSpPr>
         <p:spPr>
           <a:xfrm>
-            <a:off x="457200" y="1535112"/>
-            <a:ext cx="4040188" cy="750887"/>
+            <a:off x="609600" y="1535115"/>
+            <a:ext cx="5386917" cy="639763"/>
           </a:xfrm>
         </p:spPr>
         <p:txBody>
-          <a:bodyPr anchor="ctr"/>
+          <a:bodyPr anchor="b"/>
           <a:lstStyle>
             <a:lvl1pPr marL="0" indent="0">
               <a:buNone/>
-              <a:defRPr sz="2400" b="0" cap="all" baseline="0">
-                <a:solidFill>
-                  <a:schemeClr val="tx1"/>
-                </a:solidFill>
-              </a:defRPr>
+              <a:defRPr sz="2400" b="1"/>
             </a:lvl1pPr>
-            <a:lvl2pPr>
+            <a:lvl2pPr marL="457189" indent="0">
               <a:buNone/>
               <a:defRPr sz="2000" b="1"/>
             </a:lvl2pPr>
-            <a:lvl3pPr>
+            <a:lvl3pPr marL="914378" indent="0">
               <a:buNone/>
               <a:defRPr sz="1800" b="1"/>
             </a:lvl3pPr>
-            <a:lvl4pPr>
+            <a:lvl4pPr marL="1371566" indent="0">
               <a:buNone/>
               <a:defRPr sz="1600" b="1"/>
             </a:lvl4pPr>
-            <a:lvl5pPr>
+            <a:lvl5pPr marL="1828754" indent="0">
               <a:buNone/>
               <a:defRPr sz="1600" b="1"/>
             </a:lvl5pPr>
+            <a:lvl6pPr marL="2285943" indent="0">
+              <a:buNone/>
+              <a:defRPr sz="1600" b="1"/>
+            </a:lvl6pPr>
+            <a:lvl7pPr marL="2743132" indent="0">
+              <a:buNone/>
+              <a:defRPr sz="1600" b="1"/>
+            </a:lvl7pPr>
+            <a:lvl8pPr marL="3200320" indent="0">
+              <a:buNone/>
+              <a:defRPr sz="1600" b="1"/>
+            </a:lvl8pPr>
+            <a:lvl9pPr marL="3657509" indent="0">
+              <a:buNone/>
+              <a:defRPr sz="1600" b="1"/>
+            </a:lvl9pPr>
           </a:lstStyle>
           <a:p>
-            <a:pPr lvl="0" eaLnBrk="1" latinLnBrk="0" hangingPunct="1"/>
-            <a:r>
-              <a:rPr kumimoji="0" lang="en-US" smtClean="0"/>
+            <a:pPr lvl="0"/>
+            <a:r>
+              <a:rPr lang="en-US" altLang="zh-TW"/>
               <a:t>Click to edit Master text styles</a:t>
             </a:r>
           </a:p>
@@ -1453,71 +1531,18 @@
       </p:sp>
       <p:sp>
         <p:nvSpPr>
-          <p:cNvPr id="4" name="Text Placeholder 3"/>
-          <p:cNvSpPr>
-            <a:spLocks noGrp="1"/>
-          </p:cNvSpPr>
-          <p:nvPr>
-            <p:ph type="body" sz="half" idx="3"/>
+          <p:cNvPr id="4" name="內容版面配置區 3"/>
+          <p:cNvSpPr>
+            <a:spLocks noGrp="1"/>
+          </p:cNvSpPr>
+          <p:nvPr>
+            <p:ph sz="half" idx="2"/>
           </p:nvPr>
         </p:nvSpPr>
         <p:spPr>
           <a:xfrm>
-            <a:off x="4645025" y="1535112"/>
-            <a:ext cx="4041775" cy="750887"/>
-          </a:xfrm>
-        </p:spPr>
-        <p:txBody>
-          <a:bodyPr anchor="ctr"/>
-          <a:lstStyle>
-            <a:lvl1pPr marL="0" indent="0">
-              <a:buNone/>
-              <a:defRPr sz="2400" b="0" cap="all" baseline="0">
-                <a:solidFill>
-                  <a:schemeClr val="tx1"/>
-                </a:solidFill>
-              </a:defRPr>
-            </a:lvl1pPr>
-            <a:lvl2pPr>
-              <a:buNone/>
-              <a:defRPr sz="2000" b="1"/>
-            </a:lvl2pPr>
-            <a:lvl3pPr>
-              <a:buNone/>
-              <a:defRPr sz="1800" b="1"/>
-            </a:lvl3pPr>
-            <a:lvl4pPr>
-              <a:buNone/>
-              <a:defRPr sz="1600" b="1"/>
-            </a:lvl4pPr>
-            <a:lvl5pPr>
-              <a:buNone/>
-              <a:defRPr sz="1600" b="1"/>
-            </a:lvl5pPr>
-          </a:lstStyle>
-          <a:p>
-            <a:pPr lvl="0" eaLnBrk="1" latinLnBrk="0" hangingPunct="1"/>
-            <a:r>
-              <a:rPr kumimoji="0" lang="en-US" smtClean="0"/>
-              <a:t>Click to edit Master text styles</a:t>
-            </a:r>
-          </a:p>
-        </p:txBody>
-      </p:sp>
-      <p:sp>
-        <p:nvSpPr>
-          <p:cNvPr id="5" name="Content Placeholder 4"/>
-          <p:cNvSpPr>
-            <a:spLocks noGrp="1"/>
-          </p:cNvSpPr>
-          <p:nvPr>
-            <p:ph sz="quarter" idx="2"/>
-          </p:nvPr>
-        </p:nvSpPr>
-        <p:spPr>
-          <a:xfrm>
-            <a:off x="457200" y="2362200"/>
-            <a:ext cx="4040188" cy="3763963"/>
+            <a:off x="609600" y="2174875"/>
+            <a:ext cx="5386917" cy="3951288"/>
           </a:xfrm>
         </p:spPr>
         <p:txBody>
@@ -1538,59 +1563,136 @@
             <a:lvl5pPr>
               <a:defRPr sz="1600"/>
             </a:lvl5pPr>
+            <a:lvl6pPr>
+              <a:defRPr sz="1600"/>
+            </a:lvl6pPr>
+            <a:lvl7pPr>
+              <a:defRPr sz="1600"/>
+            </a:lvl7pPr>
+            <a:lvl8pPr>
+              <a:defRPr sz="1600"/>
+            </a:lvl8pPr>
+            <a:lvl9pPr>
+              <a:defRPr sz="1600"/>
+            </a:lvl9pPr>
           </a:lstStyle>
           <a:p>
-            <a:pPr lvl="0" eaLnBrk="1" latinLnBrk="0" hangingPunct="1"/>
-            <a:r>
-              <a:rPr lang="en-US" smtClean="0"/>
+            <a:pPr lvl="0"/>
+            <a:r>
+              <a:rPr lang="en-US" altLang="zh-TW"/>
               <a:t>Click to edit Master text styles</a:t>
             </a:r>
           </a:p>
           <a:p>
-            <a:pPr lvl="1" eaLnBrk="1" latinLnBrk="0" hangingPunct="1"/>
-            <a:r>
-              <a:rPr lang="en-US" smtClean="0"/>
+            <a:pPr lvl="1"/>
+            <a:r>
+              <a:rPr lang="en-US" altLang="zh-TW"/>
               <a:t>Second level</a:t>
             </a:r>
           </a:p>
           <a:p>
-            <a:pPr lvl="2" eaLnBrk="1" latinLnBrk="0" hangingPunct="1"/>
-            <a:r>
-              <a:rPr lang="en-US" smtClean="0"/>
+            <a:pPr lvl="2"/>
+            <a:r>
+              <a:rPr lang="en-US" altLang="zh-TW"/>
               <a:t>Third level</a:t>
             </a:r>
           </a:p>
           <a:p>
-            <a:pPr lvl="3" eaLnBrk="1" latinLnBrk="0" hangingPunct="1"/>
-            <a:r>
-              <a:rPr lang="en-US" smtClean="0"/>
+            <a:pPr lvl="3"/>
+            <a:r>
+              <a:rPr lang="en-US" altLang="zh-TW"/>
               <a:t>Fourth level</a:t>
             </a:r>
           </a:p>
           <a:p>
-            <a:pPr lvl="4" eaLnBrk="1" latinLnBrk="0" hangingPunct="1"/>
-            <a:r>
-              <a:rPr lang="en-US" smtClean="0"/>
+            <a:pPr lvl="4"/>
+            <a:r>
+              <a:rPr lang="en-US" altLang="zh-TW"/>
               <a:t>Fifth level</a:t>
             </a:r>
-            <a:endParaRPr kumimoji="0" lang="en-US"/>
-          </a:p>
-        </p:txBody>
-      </p:sp>
-      <p:sp>
-        <p:nvSpPr>
-          <p:cNvPr id="6" name="Content Placeholder 5"/>
-          <p:cNvSpPr>
-            <a:spLocks noGrp="1"/>
-          </p:cNvSpPr>
-          <p:nvPr>
-            <p:ph sz="quarter" idx="4"/>
+            <a:endParaRPr lang="zh-TW" altLang="en-US"/>
+          </a:p>
+        </p:txBody>
+      </p:sp>
+      <p:sp>
+        <p:nvSpPr>
+          <p:cNvPr id="5" name="文字版面配置區 4"/>
+          <p:cNvSpPr>
+            <a:spLocks noGrp="1"/>
+          </p:cNvSpPr>
+          <p:nvPr>
+            <p:ph type="body" sz="quarter" idx="3"/>
           </p:nvPr>
         </p:nvSpPr>
         <p:spPr>
           <a:xfrm>
-            <a:off x="4645025" y="2362200"/>
-            <a:ext cx="4041775" cy="3763963"/>
+            <a:off x="6193373" y="1535115"/>
+            <a:ext cx="5389033" cy="639763"/>
+          </a:xfrm>
+        </p:spPr>
+        <p:txBody>
+          <a:bodyPr anchor="b"/>
+          <a:lstStyle>
+            <a:lvl1pPr marL="0" indent="0">
+              <a:buNone/>
+              <a:defRPr sz="2400" b="1"/>
+            </a:lvl1pPr>
+            <a:lvl2pPr marL="457189" indent="0">
+              <a:buNone/>
+              <a:defRPr sz="2000" b="1"/>
+            </a:lvl2pPr>
+            <a:lvl3pPr marL="914378" indent="0">
+              <a:buNone/>
+              <a:defRPr sz="1800" b="1"/>
+            </a:lvl3pPr>
+            <a:lvl4pPr marL="1371566" indent="0">
+              <a:buNone/>
+              <a:defRPr sz="1600" b="1"/>
+            </a:lvl4pPr>
+            <a:lvl5pPr marL="1828754" indent="0">
+              <a:buNone/>
+              <a:defRPr sz="1600" b="1"/>
+            </a:lvl5pPr>
+            <a:lvl6pPr marL="2285943" indent="0">
+              <a:buNone/>
+              <a:defRPr sz="1600" b="1"/>
+            </a:lvl6pPr>
+            <a:lvl7pPr marL="2743132" indent="0">
+              <a:buNone/>
+              <a:defRPr sz="1600" b="1"/>
+            </a:lvl7pPr>
+            <a:lvl8pPr marL="3200320" indent="0">
+              <a:buNone/>
+              <a:defRPr sz="1600" b="1"/>
+            </a:lvl8pPr>
+            <a:lvl9pPr marL="3657509" indent="0">
+              <a:buNone/>
+              <a:defRPr sz="1600" b="1"/>
+            </a:lvl9pPr>
+          </a:lstStyle>
+          <a:p>
+            <a:pPr lvl="0"/>
+            <a:r>
+              <a:rPr lang="en-US" altLang="zh-TW"/>
+              <a:t>Click to edit Master text styles</a:t>
+            </a:r>
+          </a:p>
+        </p:txBody>
+      </p:sp>
+      <p:sp>
+        <p:nvSpPr>
+          <p:cNvPr id="6" name="內容版面配置區 5"/>
+          <p:cNvSpPr>
+            <a:spLocks noGrp="1"/>
+          </p:cNvSpPr>
+          <p:nvPr>
+            <p:ph sz="quarter" idx="4"/>
+          </p:nvPr>
+        </p:nvSpPr>
+        <p:spPr>
+          <a:xfrm>
+            <a:off x="6193373" y="2174875"/>
+            <a:ext cx="5389033" cy="3951288"/>
           </a:xfrm>
         </p:spPr>
         <p:txBody>
@@ -1611,48 +1713,60 @@
             <a:lvl5pPr>
               <a:defRPr sz="1600"/>
             </a:lvl5pPr>
+            <a:lvl6pPr>
+              <a:defRPr sz="1600"/>
+            </a:lvl6pPr>
+            <a:lvl7pPr>
+              <a:defRPr sz="1600"/>
+            </a:lvl7pPr>
+            <a:lvl8pPr>
+              <a:defRPr sz="1600"/>
+            </a:lvl8pPr>
+            <a:lvl9pPr>
+              <a:defRPr sz="1600"/>
+            </a:lvl9pPr>
           </a:lstStyle>
           <a:p>
-            <a:pPr lvl="0" eaLnBrk="1" latinLnBrk="0" hangingPunct="1"/>
-            <a:r>
-              <a:rPr lang="en-US" smtClean="0"/>
+            <a:pPr lvl="0"/>
+            <a:r>
+              <a:rPr lang="en-US" altLang="zh-TW"/>
               <a:t>Click to edit Master text styles</a:t>
             </a:r>
           </a:p>
           <a:p>
-            <a:pPr lvl="1" eaLnBrk="1" latinLnBrk="0" hangingPunct="1"/>
-            <a:r>
-              <a:rPr lang="en-US" smtClean="0"/>
+            <a:pPr lvl="1"/>
+            <a:r>
+              <a:rPr lang="en-US" altLang="zh-TW"/>
               <a:t>Second level</a:t>
             </a:r>
           </a:p>
           <a:p>
-            <a:pPr lvl="2" eaLnBrk="1" latinLnBrk="0" hangingPunct="1"/>
-            <a:r>
-              <a:rPr lang="en-US" smtClean="0"/>
+            <a:pPr lvl="2"/>
+            <a:r>
+              <a:rPr lang="en-US" altLang="zh-TW"/>
               <a:t>Third level</a:t>
             </a:r>
           </a:p>
           <a:p>
-            <a:pPr lvl="3" eaLnBrk="1" latinLnBrk="0" hangingPunct="1"/>
-            <a:r>
-              <a:rPr lang="en-US" smtClean="0"/>
+            <a:pPr lvl="3"/>
+            <a:r>
+              <a:rPr lang="en-US" altLang="zh-TW"/>
               <a:t>Fourth level</a:t>
             </a:r>
           </a:p>
           <a:p>
-            <a:pPr lvl="4" eaLnBrk="1" latinLnBrk="0" hangingPunct="1"/>
-            <a:r>
-              <a:rPr lang="en-US" smtClean="0"/>
+            <a:pPr lvl="4"/>
+            <a:r>
+              <a:rPr lang="en-US" altLang="zh-TW"/>
               <a:t>Fifth level</a:t>
             </a:r>
-            <a:endParaRPr kumimoji="0" lang="en-US"/>
-          </a:p>
-        </p:txBody>
-      </p:sp>
-      <p:sp>
-        <p:nvSpPr>
-          <p:cNvPr id="7" name="Date Placeholder 6"/>
+            <a:endParaRPr lang="zh-TW" altLang="en-US"/>
+          </a:p>
+        </p:txBody>
+      </p:sp>
+      <p:sp>
+        <p:nvSpPr>
+          <p:cNvPr id="7" name="日期版面配置區 6"/>
           <p:cNvSpPr>
             <a:spLocks noGrp="1"/>
           </p:cNvSpPr>
@@ -1667,7 +1781,7 @@
           <a:p>
             <a:fld id="{E43ECC0B-00A7-4233-BD1F-1580B09B8357}" type="datetimeFigureOut">
               <a:rPr lang="en-US" smtClean="0"/>
-              <a:t>2/16/2013</a:t>
+              <a:t>6/30/2025</a:t>
             </a:fld>
             <a:endParaRPr lang="en-US"/>
           </a:p>
@@ -1675,7 +1789,7 @@
       </p:sp>
       <p:sp>
         <p:nvSpPr>
-          <p:cNvPr id="8" name="Footer Placeholder 7"/>
+          <p:cNvPr id="8" name="頁尾版面配置區 7"/>
           <p:cNvSpPr>
             <a:spLocks noGrp="1"/>
           </p:cNvSpPr>
@@ -1694,7 +1808,7 @@
       </p:sp>
       <p:sp>
         <p:nvSpPr>
-          <p:cNvPr id="9" name="Slide Number Placeholder 8"/>
+          <p:cNvPr id="9" name="投影片編號版面配置區 8"/>
           <p:cNvSpPr>
             <a:spLocks noGrp="1"/>
           </p:cNvSpPr>
@@ -1716,6 +1830,11 @@
         </p:txBody>
       </p:sp>
     </p:spTree>
+    <p:extLst>
+      <p:ext uri="{BB962C8B-B14F-4D97-AF65-F5344CB8AC3E}">
+        <p14:creationId xmlns:p14="http://schemas.microsoft.com/office/powerpoint/2010/main" val="3053293076"/>
+      </p:ext>
+    </p:extLst>
   </p:cSld>
   <p:clrMapOvr>
     <a:masterClrMapping/>
@@ -1725,7 +1844,7 @@
 
 <file path=ppt/slideLayouts/slideLayout6.xml><?xml version="1.0" encoding="utf-8"?>
 <p:sldLayout xmlns:a="http://schemas.openxmlformats.org/drawingml/2006/main" xmlns:r="http://schemas.openxmlformats.org/officeDocument/2006/relationships" xmlns:p="http://schemas.openxmlformats.org/presentationml/2006/main" type="titleOnly" preserve="1">
-  <p:cSld name="Title Only">
+  <p:cSld name="只有標題">
     <p:spTree>
       <p:nvGrpSpPr>
         <p:cNvPr id="1" name=""/>
@@ -1742,7 +1861,7 @@
       </p:grpSpPr>
       <p:sp>
         <p:nvSpPr>
-          <p:cNvPr id="2" name="Title 1"/>
+          <p:cNvPr id="2" name="標題 1"/>
           <p:cNvSpPr>
             <a:spLocks noGrp="1"/>
           </p:cNvSpPr>
@@ -1756,16 +1875,16 @@
           <a:lstStyle/>
           <a:p>
             <a:r>
-              <a:rPr kumimoji="0" lang="en-US" smtClean="0"/>
+              <a:rPr lang="en-US" altLang="zh-TW"/>
               <a:t>Click to edit Master title style</a:t>
             </a:r>
-            <a:endParaRPr kumimoji="0" lang="en-US"/>
-          </a:p>
-        </p:txBody>
-      </p:sp>
-      <p:sp>
-        <p:nvSpPr>
-          <p:cNvPr id="3" name="Date Placeholder 2"/>
+            <a:endParaRPr lang="zh-TW" altLang="en-US"/>
+          </a:p>
+        </p:txBody>
+      </p:sp>
+      <p:sp>
+        <p:nvSpPr>
+          <p:cNvPr id="3" name="日期版面配置區 2"/>
           <p:cNvSpPr>
             <a:spLocks noGrp="1"/>
           </p:cNvSpPr>
@@ -1780,7 +1899,7 @@
           <a:p>
             <a:fld id="{E43ECC0B-00A7-4233-BD1F-1580B09B8357}" type="datetimeFigureOut">
               <a:rPr lang="en-US" smtClean="0"/>
-              <a:t>2/16/2013</a:t>
+              <a:t>6/30/2025</a:t>
             </a:fld>
             <a:endParaRPr lang="en-US"/>
           </a:p>
@@ -1788,7 +1907,7 @@
       </p:sp>
       <p:sp>
         <p:nvSpPr>
-          <p:cNvPr id="4" name="Footer Placeholder 3"/>
+          <p:cNvPr id="4" name="頁尾版面配置區 3"/>
           <p:cNvSpPr>
             <a:spLocks noGrp="1"/>
           </p:cNvSpPr>
@@ -1807,7 +1926,7 @@
       </p:sp>
       <p:sp>
         <p:nvSpPr>
-          <p:cNvPr id="5" name="Slide Number Placeholder 4"/>
+          <p:cNvPr id="5" name="投影片編號版面配置區 4"/>
           <p:cNvSpPr>
             <a:spLocks noGrp="1"/>
           </p:cNvSpPr>
@@ -1829,6 +1948,11 @@
         </p:txBody>
       </p:sp>
     </p:spTree>
+    <p:extLst>
+      <p:ext uri="{BB962C8B-B14F-4D97-AF65-F5344CB8AC3E}">
+        <p14:creationId xmlns:p14="http://schemas.microsoft.com/office/powerpoint/2010/main" val="127436044"/>
+      </p:ext>
+    </p:extLst>
   </p:cSld>
   <p:clrMapOvr>
     <a:masterClrMapping/>
@@ -1838,7 +1962,7 @@
 
 <file path=ppt/slideLayouts/slideLayout7.xml><?xml version="1.0" encoding="utf-8"?>
 <p:sldLayout xmlns:a="http://schemas.openxmlformats.org/drawingml/2006/main" xmlns:r="http://schemas.openxmlformats.org/officeDocument/2006/relationships" xmlns:p="http://schemas.openxmlformats.org/presentationml/2006/main" type="blank" preserve="1">
-  <p:cSld name="Blank">
+  <p:cSld name="空白">
     <p:spTree>
       <p:nvGrpSpPr>
         <p:cNvPr id="1" name=""/>
@@ -1855,7 +1979,7 @@
       </p:grpSpPr>
       <p:sp>
         <p:nvSpPr>
-          <p:cNvPr id="2" name="Date Placeholder 1"/>
+          <p:cNvPr id="2" name="日期版面配置區 1"/>
           <p:cNvSpPr>
             <a:spLocks noGrp="1"/>
           </p:cNvSpPr>
@@ -1870,7 +1994,7 @@
           <a:p>
             <a:fld id="{E43ECC0B-00A7-4233-BD1F-1580B09B8357}" type="datetimeFigureOut">
               <a:rPr lang="en-US" smtClean="0"/>
-              <a:t>2/16/2013</a:t>
+              <a:t>6/30/2025</a:t>
             </a:fld>
             <a:endParaRPr lang="en-US"/>
           </a:p>
@@ -1878,7 +2002,7 @@
       </p:sp>
       <p:sp>
         <p:nvSpPr>
-          <p:cNvPr id="3" name="Footer Placeholder 2"/>
+          <p:cNvPr id="3" name="頁尾版面配置區 2"/>
           <p:cNvSpPr>
             <a:spLocks noGrp="1"/>
           </p:cNvSpPr>
@@ -1897,7 +2021,7 @@
       </p:sp>
       <p:sp>
         <p:nvSpPr>
-          <p:cNvPr id="4" name="Slide Number Placeholder 3"/>
+          <p:cNvPr id="4" name="投影片編號版面配置區 3"/>
           <p:cNvSpPr>
             <a:spLocks noGrp="1"/>
           </p:cNvSpPr>
@@ -1919,6 +2043,11 @@
         </p:txBody>
       </p:sp>
     </p:spTree>
+    <p:extLst>
+      <p:ext uri="{BB962C8B-B14F-4D97-AF65-F5344CB8AC3E}">
+        <p14:creationId xmlns:p14="http://schemas.microsoft.com/office/powerpoint/2010/main" val="2148945237"/>
+      </p:ext>
+    </p:extLst>
   </p:cSld>
   <p:clrMapOvr>
     <a:masterClrMapping/>
@@ -1928,7 +2057,7 @@
 
 <file path=ppt/slideLayouts/slideLayout8.xml><?xml version="1.0" encoding="utf-8"?>
 <p:sldLayout xmlns:a="http://schemas.openxmlformats.org/drawingml/2006/main" xmlns:r="http://schemas.openxmlformats.org/officeDocument/2006/relationships" xmlns:p="http://schemas.openxmlformats.org/presentationml/2006/main" type="objTx" preserve="1">
-  <p:cSld name="Content with Caption">
+  <p:cSld name="含標題的內容">
     <p:spTree>
       <p:nvGrpSpPr>
         <p:cNvPr id="1" name=""/>
@@ -1945,7 +2074,7 @@
       </p:grpSpPr>
       <p:sp>
         <p:nvSpPr>
-          <p:cNvPr id="2" name="Title 1"/>
+          <p:cNvPr id="2" name="標題 1"/>
           <p:cNvSpPr>
             <a:spLocks noGrp="1"/>
           </p:cNvSpPr>
@@ -1955,165 +2084,179 @@
         </p:nvSpPr>
         <p:spPr>
           <a:xfrm>
-            <a:off x="457200" y="273050"/>
-            <a:ext cx="3008313" cy="1162050"/>
+            <a:off x="609603" y="273051"/>
+            <a:ext cx="4011084" cy="1162051"/>
           </a:xfrm>
         </p:spPr>
         <p:txBody>
-          <a:bodyPr vert="horz" anchor="b">
-            <a:normAutofit/>
-            <a:sp3d prstMaterial="softEdge"/>
-          </a:bodyPr>
+          <a:bodyPr anchor="b"/>
           <a:lstStyle>
             <a:lvl1pPr algn="l">
-              <a:buNone/>
-              <a:defRPr sz="2200" b="0">
-                <a:ln w="6350">
-                  <a:noFill/>
-                </a:ln>
-                <a:solidFill>
-                  <a:schemeClr val="accent1">
-                    <a:tint val="73000"/>
-                    <a:satMod val="180000"/>
-                  </a:schemeClr>
-                </a:solidFill>
-              </a:defRPr>
+              <a:defRPr sz="2000" b="1"/>
             </a:lvl1pPr>
           </a:lstStyle>
           <a:p>
             <a:r>
-              <a:rPr kumimoji="0" lang="en-US" smtClean="0"/>
+              <a:rPr lang="en-US" altLang="zh-TW"/>
               <a:t>Click to edit Master title style</a:t>
             </a:r>
-            <a:endParaRPr kumimoji="0" lang="en-US"/>
-          </a:p>
-        </p:txBody>
-      </p:sp>
-      <p:sp>
-        <p:nvSpPr>
-          <p:cNvPr id="3" name="Text Placeholder 2"/>
-          <p:cNvSpPr>
-            <a:spLocks noGrp="1"/>
-          </p:cNvSpPr>
-          <p:nvPr>
-            <p:ph type="body" idx="2"/>
+            <a:endParaRPr lang="zh-TW" altLang="en-US"/>
+          </a:p>
+        </p:txBody>
+      </p:sp>
+      <p:sp>
+        <p:nvSpPr>
+          <p:cNvPr id="3" name="內容版面配置區 2"/>
+          <p:cNvSpPr>
+            <a:spLocks noGrp="1"/>
+          </p:cNvSpPr>
+          <p:nvPr>
+            <p:ph idx="1"/>
           </p:nvPr>
         </p:nvSpPr>
         <p:spPr>
           <a:xfrm>
-            <a:off x="457200" y="1524000"/>
-            <a:ext cx="3008313" cy="4602163"/>
+            <a:off x="4766733" y="273055"/>
+            <a:ext cx="6815667" cy="5853113"/>
           </a:xfrm>
         </p:spPr>
         <p:txBody>
           <a:bodyPr/>
           <a:lstStyle>
-            <a:lvl1pPr marL="0" indent="0">
-              <a:buNone/>
-              <a:defRPr sz="1400"/>
+            <a:lvl1pPr>
+              <a:defRPr sz="3200"/>
             </a:lvl1pPr>
             <a:lvl2pPr>
-              <a:buNone/>
-              <a:defRPr sz="1200"/>
+              <a:defRPr sz="2800"/>
             </a:lvl2pPr>
             <a:lvl3pPr>
-              <a:buNone/>
-              <a:defRPr sz="1000"/>
-            </a:lvl3pPr>
-            <a:lvl4pPr>
-              <a:buNone/>
-              <a:defRPr sz="900"/>
-            </a:lvl4pPr>
-            <a:lvl5pPr>
-              <a:buNone/>
-              <a:defRPr sz="900"/>
-            </a:lvl5pPr>
-          </a:lstStyle>
-          <a:p>
-            <a:pPr lvl="0" eaLnBrk="1" latinLnBrk="0" hangingPunct="1"/>
-            <a:r>
-              <a:rPr kumimoji="0" lang="en-US" smtClean="0"/>
-              <a:t>Click to edit Master text styles</a:t>
-            </a:r>
-          </a:p>
-        </p:txBody>
-      </p:sp>
-      <p:sp>
-        <p:nvSpPr>
-          <p:cNvPr id="4" name="Content Placeholder 3"/>
-          <p:cNvSpPr>
-            <a:spLocks noGrp="1"/>
-          </p:cNvSpPr>
-          <p:nvPr>
-            <p:ph sz="half" idx="1"/>
-          </p:nvPr>
-        </p:nvSpPr>
-        <p:spPr>
-          <a:xfrm>
-            <a:off x="3575050" y="273050"/>
-            <a:ext cx="5111750" cy="5853113"/>
-          </a:xfrm>
-        </p:spPr>
-        <p:txBody>
-          <a:bodyPr/>
-          <a:lstStyle>
-            <a:lvl1pPr>
-              <a:defRPr sz="2600"/>
-            </a:lvl1pPr>
-            <a:lvl2pPr>
               <a:defRPr sz="2400"/>
-            </a:lvl2pPr>
-            <a:lvl3pPr>
-              <a:defRPr sz="2200"/>
             </a:lvl3pPr>
             <a:lvl4pPr>
               <a:defRPr sz="2000"/>
             </a:lvl4pPr>
             <a:lvl5pPr>
-              <a:defRPr sz="1800"/>
+              <a:defRPr sz="2000"/>
             </a:lvl5pPr>
+            <a:lvl6pPr>
+              <a:defRPr sz="2000"/>
+            </a:lvl6pPr>
+            <a:lvl7pPr>
+              <a:defRPr sz="2000"/>
+            </a:lvl7pPr>
+            <a:lvl8pPr>
+              <a:defRPr sz="2000"/>
+            </a:lvl8pPr>
+            <a:lvl9pPr>
+              <a:defRPr sz="2000"/>
+            </a:lvl9pPr>
           </a:lstStyle>
           <a:p>
-            <a:pPr lvl="0" eaLnBrk="1" latinLnBrk="0" hangingPunct="1"/>
-            <a:r>
-              <a:rPr lang="en-US" smtClean="0"/>
+            <a:pPr lvl="0"/>
+            <a:r>
+              <a:rPr lang="en-US" altLang="zh-TW"/>
               <a:t>Click to edit Master text styles</a:t>
             </a:r>
           </a:p>
           <a:p>
-            <a:pPr lvl="1" eaLnBrk="1" latinLnBrk="0" hangingPunct="1"/>
-            <a:r>
-              <a:rPr lang="en-US" smtClean="0"/>
+            <a:pPr lvl="1"/>
+            <a:r>
+              <a:rPr lang="en-US" altLang="zh-TW"/>
               <a:t>Second level</a:t>
             </a:r>
           </a:p>
           <a:p>
-            <a:pPr lvl="2" eaLnBrk="1" latinLnBrk="0" hangingPunct="1"/>
-            <a:r>
-              <a:rPr lang="en-US" smtClean="0"/>
+            <a:pPr lvl="2"/>
+            <a:r>
+              <a:rPr lang="en-US" altLang="zh-TW"/>
               <a:t>Third level</a:t>
             </a:r>
           </a:p>
           <a:p>
-            <a:pPr lvl="3" eaLnBrk="1" latinLnBrk="0" hangingPunct="1"/>
-            <a:r>
-              <a:rPr lang="en-US" smtClean="0"/>
+            <a:pPr lvl="3"/>
+            <a:r>
+              <a:rPr lang="en-US" altLang="zh-TW"/>
               <a:t>Fourth level</a:t>
             </a:r>
           </a:p>
           <a:p>
-            <a:pPr lvl="4" eaLnBrk="1" latinLnBrk="0" hangingPunct="1"/>
-            <a:r>
-              <a:rPr lang="en-US" smtClean="0"/>
+            <a:pPr lvl="4"/>
+            <a:r>
+              <a:rPr lang="en-US" altLang="zh-TW"/>
               <a:t>Fifth level</a:t>
             </a:r>
-            <a:endParaRPr kumimoji="0" lang="en-US"/>
-          </a:p>
-        </p:txBody>
-      </p:sp>
-      <p:sp>
-        <p:nvSpPr>
-          <p:cNvPr id="5" name="Date Placeholder 4"/>
+            <a:endParaRPr lang="zh-TW" altLang="en-US"/>
+          </a:p>
+        </p:txBody>
+      </p:sp>
+      <p:sp>
+        <p:nvSpPr>
+          <p:cNvPr id="4" name="文字版面配置區 3"/>
+          <p:cNvSpPr>
+            <a:spLocks noGrp="1"/>
+          </p:cNvSpPr>
+          <p:nvPr>
+            <p:ph type="body" sz="half" idx="2"/>
+          </p:nvPr>
+        </p:nvSpPr>
+        <p:spPr>
+          <a:xfrm>
+            <a:off x="609603" y="1435103"/>
+            <a:ext cx="4011084" cy="4691063"/>
+          </a:xfrm>
+        </p:spPr>
+        <p:txBody>
+          <a:bodyPr/>
+          <a:lstStyle>
+            <a:lvl1pPr marL="0" indent="0">
+              <a:buNone/>
+              <a:defRPr sz="1400"/>
+            </a:lvl1pPr>
+            <a:lvl2pPr marL="457189" indent="0">
+              <a:buNone/>
+              <a:defRPr sz="1200"/>
+            </a:lvl2pPr>
+            <a:lvl3pPr marL="914378" indent="0">
+              <a:buNone/>
+              <a:defRPr sz="1000"/>
+            </a:lvl3pPr>
+            <a:lvl4pPr marL="1371566" indent="0">
+              <a:buNone/>
+              <a:defRPr sz="900"/>
+            </a:lvl4pPr>
+            <a:lvl5pPr marL="1828754" indent="0">
+              <a:buNone/>
+              <a:defRPr sz="900"/>
+            </a:lvl5pPr>
+            <a:lvl6pPr marL="2285943" indent="0">
+              <a:buNone/>
+              <a:defRPr sz="900"/>
+            </a:lvl6pPr>
+            <a:lvl7pPr marL="2743132" indent="0">
+              <a:buNone/>
+              <a:defRPr sz="900"/>
+            </a:lvl7pPr>
+            <a:lvl8pPr marL="3200320" indent="0">
+              <a:buNone/>
+              <a:defRPr sz="900"/>
+            </a:lvl8pPr>
+            <a:lvl9pPr marL="3657509" indent="0">
+              <a:buNone/>
+              <a:defRPr sz="900"/>
+            </a:lvl9pPr>
+          </a:lstStyle>
+          <a:p>
+            <a:pPr lvl="0"/>
+            <a:r>
+              <a:rPr lang="en-US" altLang="zh-TW"/>
+              <a:t>Click to edit Master text styles</a:t>
+            </a:r>
+          </a:p>
+        </p:txBody>
+      </p:sp>
+      <p:sp>
+        <p:nvSpPr>
+          <p:cNvPr id="5" name="日期版面配置區 4"/>
           <p:cNvSpPr>
             <a:spLocks noGrp="1"/>
           </p:cNvSpPr>
@@ -2128,7 +2271,7 @@
           <a:p>
             <a:fld id="{E43ECC0B-00A7-4233-BD1F-1580B09B8357}" type="datetimeFigureOut">
               <a:rPr lang="en-US" smtClean="0"/>
-              <a:t>2/16/2013</a:t>
+              <a:t>6/30/2025</a:t>
             </a:fld>
             <a:endParaRPr lang="en-US"/>
           </a:p>
@@ -2136,7 +2279,7 @@
       </p:sp>
       <p:sp>
         <p:nvSpPr>
-          <p:cNvPr id="6" name="Footer Placeholder 5"/>
+          <p:cNvPr id="6" name="頁尾版面配置區 5"/>
           <p:cNvSpPr>
             <a:spLocks noGrp="1"/>
           </p:cNvSpPr>
@@ -2155,7 +2298,7 @@
       </p:sp>
       <p:sp>
         <p:nvSpPr>
-          <p:cNvPr id="7" name="Slide Number Placeholder 6"/>
+          <p:cNvPr id="7" name="投影片編號版面配置區 6"/>
           <p:cNvSpPr>
             <a:spLocks noGrp="1"/>
           </p:cNvSpPr>
@@ -2177,6 +2320,11 @@
         </p:txBody>
       </p:sp>
     </p:spTree>
+    <p:extLst>
+      <p:ext uri="{BB962C8B-B14F-4D97-AF65-F5344CB8AC3E}">
+        <p14:creationId xmlns:p14="http://schemas.microsoft.com/office/powerpoint/2010/main" val="2806034947"/>
+      </p:ext>
+    </p:extLst>
   </p:cSld>
   <p:clrMapOvr>
     <a:masterClrMapping/>
@@ -2186,7 +2334,7 @@
 
 <file path=ppt/slideLayouts/slideLayout9.xml><?xml version="1.0" encoding="utf-8"?>
 <p:sldLayout xmlns:a="http://schemas.openxmlformats.org/drawingml/2006/main" xmlns:r="http://schemas.openxmlformats.org/officeDocument/2006/relationships" xmlns:p="http://schemas.openxmlformats.org/presentationml/2006/main" type="picTx" preserve="1">
-  <p:cSld name="Picture with Caption">
+  <p:cSld name="含標題的圖片">
     <p:spTree>
       <p:nvGrpSpPr>
         <p:cNvPr id="1" name=""/>
@@ -2203,7 +2351,7 @@
       </p:grpSpPr>
       <p:sp>
         <p:nvSpPr>
-          <p:cNvPr id="2" name="Title 1"/>
+          <p:cNvPr id="2" name="標題 1"/>
           <p:cNvSpPr>
             <a:spLocks noGrp="1"/>
           </p:cNvSpPr>
@@ -2213,32 +2361,29 @@
         </p:nvSpPr>
         <p:spPr>
           <a:xfrm>
-            <a:off x="1828800" y="609600"/>
-            <a:ext cx="5486400" cy="522288"/>
+            <a:off x="2389717" y="4800603"/>
+            <a:ext cx="7315200" cy="566739"/>
           </a:xfrm>
         </p:spPr>
         <p:txBody>
-          <a:bodyPr lIns="45720" rIns="45720" bIns="0" anchor="b">
-            <a:sp3d prstMaterial="softEdge"/>
-          </a:bodyPr>
+          <a:bodyPr anchor="b"/>
           <a:lstStyle>
-            <a:lvl1pPr algn="ctr">
-              <a:buNone/>
+            <a:lvl1pPr algn="l">
               <a:defRPr sz="2000" b="1"/>
             </a:lvl1pPr>
           </a:lstStyle>
           <a:p>
             <a:r>
-              <a:rPr kumimoji="0" lang="en-US" smtClean="0"/>
+              <a:rPr lang="en-US" altLang="zh-TW"/>
               <a:t>Click to edit Master title style</a:t>
             </a:r>
-            <a:endParaRPr kumimoji="0" lang="en-US"/>
-          </a:p>
-        </p:txBody>
-      </p:sp>
-      <p:sp>
-        <p:nvSpPr>
-          <p:cNvPr id="3" name="Picture Placeholder 2"/>
+            <a:endParaRPr lang="zh-TW" altLang="en-US"/>
+          </a:p>
+        </p:txBody>
+      </p:sp>
+      <p:sp>
+        <p:nvSpPr>
+          <p:cNvPr id="3" name="圖片版面配置區 2"/>
           <p:cNvSpPr>
             <a:spLocks noGrp="1"/>
           </p:cNvSpPr>
@@ -2248,91 +2393,62 @@
         </p:nvSpPr>
         <p:spPr>
           <a:xfrm>
-            <a:off x="1828800" y="1831975"/>
-            <a:ext cx="5486400" cy="3962400"/>
+            <a:off x="2389717" y="612775"/>
+            <a:ext cx="7315200" cy="4114800"/>
           </a:xfrm>
-          <a:solidFill>
-            <a:schemeClr val="bg2"/>
-          </a:solidFill>
-          <a:ln w="44450" cap="sq" cmpd="sng" algn="ctr">
-            <a:solidFill>
-              <a:srgbClr val="FFFFFF"/>
-            </a:solidFill>
-            <a:prstDash val="solid"/>
-            <a:miter lim="800000"/>
-          </a:ln>
-          <a:effectLst>
-            <a:outerShdw blurRad="190500" dist="228600" dir="2700000" sy="90000">
-              <a:srgbClr val="000000">
-                <a:alpha val="25000"/>
-              </a:srgbClr>
-            </a:outerShdw>
-          </a:effectLst>
-          <a:scene3d>
-            <a:camera prst="orthographicFront">
-              <a:rot lat="0" lon="0" rev="0"/>
-            </a:camera>
-            <a:lightRig rig="balanced" dir="tr">
-              <a:rot lat="0" lon="0" rev="2700000"/>
-            </a:lightRig>
-          </a:scene3d>
-          <a:sp3d prstMaterial="matte">
-            <a:contourClr>
-              <a:schemeClr val="tx2">
-                <a:shade val="50000"/>
-              </a:schemeClr>
-            </a:contourClr>
-          </a:sp3d>
         </p:spPr>
-        <p:style>
-          <a:lnRef idx="3">
-            <a:schemeClr val="lt1"/>
-          </a:lnRef>
-          <a:fillRef idx="1">
-            <a:schemeClr val="accent1"/>
-          </a:fillRef>
-          <a:effectRef idx="1">
-            <a:schemeClr val="accent1"/>
-          </a:effectRef>
-          <a:fontRef idx="minor">
-            <a:schemeClr val="lt1"/>
-          </a:fontRef>
-        </p:style>
-        <p:txBody>
-          <a:bodyPr anchor="t"/>
+        <p:txBody>
+          <a:bodyPr/>
           <a:lstStyle>
-            <a:lvl1pPr indent="0">
+            <a:lvl1pPr marL="0" indent="0">
               <a:buNone/>
               <a:defRPr sz="3200"/>
             </a:lvl1pPr>
+            <a:lvl2pPr marL="457189" indent="0">
+              <a:buNone/>
+              <a:defRPr sz="2800"/>
+            </a:lvl2pPr>
+            <a:lvl3pPr marL="914378" indent="0">
+              <a:buNone/>
+              <a:defRPr sz="2400"/>
+            </a:lvl3pPr>
+            <a:lvl4pPr marL="1371566" indent="0">
+              <a:buNone/>
+              <a:defRPr sz="2000"/>
+            </a:lvl4pPr>
+            <a:lvl5pPr marL="1828754" indent="0">
+              <a:buNone/>
+              <a:defRPr sz="2000"/>
+            </a:lvl5pPr>
+            <a:lvl6pPr marL="2285943" indent="0">
+              <a:buNone/>
+              <a:defRPr sz="2000"/>
+            </a:lvl6pPr>
+            <a:lvl7pPr marL="2743132" indent="0">
+              <a:buNone/>
+              <a:defRPr sz="2000"/>
+            </a:lvl7pPr>
+            <a:lvl8pPr marL="3200320" indent="0">
+              <a:buNone/>
+              <a:defRPr sz="2000"/>
+            </a:lvl8pPr>
+            <a:lvl9pPr marL="3657509" indent="0">
+              <a:buNone/>
+              <a:defRPr sz="2000"/>
+            </a:lvl9pPr>
           </a:lstStyle>
           <a:p>
-            <a:pPr marL="0" algn="l" rtl="0" eaLnBrk="1" latinLnBrk="0" hangingPunct="1"/>
-            <a:r>
-              <a:rPr kumimoji="0" lang="en-US" smtClean="0">
-                <a:solidFill>
-                  <a:schemeClr val="lt1"/>
-                </a:solidFill>
-                <a:latin typeface="+mn-lt"/>
-                <a:ea typeface="+mn-ea"/>
-                <a:cs typeface="+mn-cs"/>
-              </a:rPr>
+            <a:r>
+              <a:rPr lang="en-US" altLang="zh-TW"/>
               <a:t>Click icon to add picture</a:t>
             </a:r>
-            <a:endParaRPr kumimoji="0" lang="en-US" dirty="0">
-              <a:solidFill>
-                <a:schemeClr val="lt1"/>
-              </a:solidFill>
-              <a:latin typeface="+mn-lt"/>
-              <a:ea typeface="+mn-ea"/>
-              <a:cs typeface="+mn-cs"/>
-            </a:endParaRPr>
-          </a:p>
-        </p:txBody>
-      </p:sp>
-      <p:sp>
-        <p:nvSpPr>
-          <p:cNvPr id="4" name="Text Placeholder 3"/>
+            <a:endParaRPr lang="zh-TW" altLang="en-US"/>
+          </a:p>
+        </p:txBody>
+      </p:sp>
+      <p:sp>
+        <p:nvSpPr>
+          <p:cNvPr id="4" name="文字版面配置區 3"/>
           <p:cNvSpPr>
             <a:spLocks noGrp="1"/>
           </p:cNvSpPr>
@@ -2342,34 +2458,54 @@
         </p:nvSpPr>
         <p:spPr>
           <a:xfrm>
-            <a:off x="1828800" y="1166787"/>
-            <a:ext cx="5486400" cy="530352"/>
+            <a:off x="2389717" y="5367341"/>
+            <a:ext cx="7315200" cy="804863"/>
           </a:xfrm>
         </p:spPr>
         <p:txBody>
-          <a:bodyPr lIns="45720" tIns="45720" rIns="45720" anchor="t"/>
+          <a:bodyPr/>
           <a:lstStyle>
-            <a:lvl1pPr marL="0" indent="0" algn="ctr">
+            <a:lvl1pPr marL="0" indent="0">
               <a:buNone/>
               <a:defRPr sz="1400"/>
             </a:lvl1pPr>
-            <a:lvl2pPr>
+            <a:lvl2pPr marL="457189" indent="0">
+              <a:buNone/>
               <a:defRPr sz="1200"/>
             </a:lvl2pPr>
-            <a:lvl3pPr>
+            <a:lvl3pPr marL="914378" indent="0">
+              <a:buNone/>
               <a:defRPr sz="1000"/>
             </a:lvl3pPr>
-            <a:lvl4pPr>
+            <a:lvl4pPr marL="1371566" indent="0">
+              <a:buNone/>
               <a:defRPr sz="900"/>
             </a:lvl4pPr>
-            <a:lvl5pPr>
+            <a:lvl5pPr marL="1828754" indent="0">
+              <a:buNone/>
               <a:defRPr sz="900"/>
             </a:lvl5pPr>
+            <a:lvl6pPr marL="2285943" indent="0">
+              <a:buNone/>
+              <a:defRPr sz="900"/>
+            </a:lvl6pPr>
+            <a:lvl7pPr marL="2743132" indent="0">
+              <a:buNone/>
+              <a:defRPr sz="900"/>
+            </a:lvl7pPr>
+            <a:lvl8pPr marL="3200320" indent="0">
+              <a:buNone/>
+              <a:defRPr sz="900"/>
+            </a:lvl8pPr>
+            <a:lvl9pPr marL="3657509" indent="0">
+              <a:buNone/>
+              <a:defRPr sz="900"/>
+            </a:lvl9pPr>
           </a:lstStyle>
           <a:p>
-            <a:pPr lvl="0" eaLnBrk="1" latinLnBrk="0" hangingPunct="1"/>
-            <a:r>
-              <a:rPr kumimoji="0" lang="en-US" smtClean="0"/>
+            <a:pPr lvl="0"/>
+            <a:r>
+              <a:rPr lang="en-US" altLang="zh-TW"/>
               <a:t>Click to edit Master text styles</a:t>
             </a:r>
           </a:p>
@@ -2377,7 +2513,7 @@
       </p:sp>
       <p:sp>
         <p:nvSpPr>
-          <p:cNvPr id="5" name="Date Placeholder 4"/>
+          <p:cNvPr id="5" name="日期版面配置區 4"/>
           <p:cNvSpPr>
             <a:spLocks noGrp="1"/>
           </p:cNvSpPr>
@@ -2392,7 +2528,7 @@
           <a:p>
             <a:fld id="{E43ECC0B-00A7-4233-BD1F-1580B09B8357}" type="datetimeFigureOut">
               <a:rPr lang="en-US" smtClean="0"/>
-              <a:t>2/16/2013</a:t>
+              <a:t>6/30/2025</a:t>
             </a:fld>
             <a:endParaRPr lang="en-US"/>
           </a:p>
@@ -2400,7 +2536,7 @@
       </p:sp>
       <p:sp>
         <p:nvSpPr>
-          <p:cNvPr id="6" name="Footer Placeholder 5"/>
+          <p:cNvPr id="6" name="頁尾版面配置區 5"/>
           <p:cNvSpPr>
             <a:spLocks noGrp="1"/>
           </p:cNvSpPr>
@@ -2419,7 +2555,7 @@
       </p:sp>
       <p:sp>
         <p:nvSpPr>
-          <p:cNvPr id="7" name="Slide Number Placeholder 6"/>
+          <p:cNvPr id="7" name="投影片編號版面配置區 6"/>
           <p:cNvSpPr>
             <a:spLocks noGrp="1"/>
           </p:cNvSpPr>
@@ -2441,6 +2577,11 @@
         </p:txBody>
       </p:sp>
     </p:spTree>
+    <p:extLst>
+      <p:ext uri="{BB962C8B-B14F-4D97-AF65-F5344CB8AC3E}">
+        <p14:creationId xmlns:p14="http://schemas.microsoft.com/office/powerpoint/2010/main" val="31719045"/>
+      </p:ext>
+    </p:extLst>
   </p:cSld>
   <p:clrMapOvr>
     <a:masterClrMapping/>
@@ -2452,9 +2593,14 @@
 <p:sldMaster xmlns:a="http://schemas.openxmlformats.org/drawingml/2006/main" xmlns:r="http://schemas.openxmlformats.org/officeDocument/2006/relationships" xmlns:p="http://schemas.openxmlformats.org/presentationml/2006/main">
   <p:cSld>
     <p:bg>
-      <p:bgRef idx="1003">
-        <a:schemeClr val="bg2"/>
-      </p:bgRef>
+      <p:bgPr>
+        <a:blipFill dpi="0" rotWithShape="1">
+          <a:blip r:embed="rId13"/>
+          <a:srcRect/>
+          <a:tile tx="0" ty="0" sx="100000" sy="100000" flip="none" algn="tl"/>
+        </a:blipFill>
+        <a:effectLst/>
+      </p:bgPr>
     </p:bg>
     <p:spTree>
       <p:nvGrpSpPr>
@@ -2472,7 +2618,7 @@
       </p:grpSpPr>
       <p:sp>
         <p:nvSpPr>
-          <p:cNvPr id="22" name="Title Placeholder 21"/>
+          <p:cNvPr id="2" name="標題版面配置區 1"/>
           <p:cNvSpPr>
             <a:spLocks noGrp="1"/>
           </p:cNvSpPr>
@@ -2482,39 +2628,29 @@
         </p:nvSpPr>
         <p:spPr>
           <a:xfrm>
-            <a:off x="457200" y="274638"/>
-            <a:ext cx="8229600" cy="1143000"/>
+            <a:off x="609600" y="274637"/>
+            <a:ext cx="10972800" cy="1143000"/>
           </a:xfrm>
           <a:prstGeom prst="rect">
             <a:avLst/>
           </a:prstGeom>
         </p:spPr>
         <p:txBody>
-          <a:bodyPr vert="horz" anchor="ctr">
+          <a:bodyPr vert="horz" lIns="91440" tIns="45720" rIns="91440" bIns="45720" rtlCol="0" anchor="ctr">
             <a:normAutofit/>
-            <a:scene3d>
-              <a:camera prst="orthographicFront"/>
-              <a:lightRig rig="soft" dir="t">
-                <a:rot lat="0" lon="0" rev="16800000"/>
-              </a:lightRig>
-            </a:scene3d>
-            <a:sp3d prstMaterial="softEdge">
-              <a:bevelT w="38100" h="38100"/>
-            </a:sp3d>
           </a:bodyPr>
           <a:lstStyle/>
           <a:p>
             <a:r>
-              <a:rPr kumimoji="0" lang="en-US" smtClean="0"/>
-              <a:t>Click to edit Master title style</a:t>
-            </a:r>
-            <a:endParaRPr kumimoji="0" lang="en-US"/>
-          </a:p>
-        </p:txBody>
-      </p:sp>
-      <p:sp>
-        <p:nvSpPr>
-          <p:cNvPr id="13" name="Text Placeholder 12"/>
+              <a:rPr lang="zh-TW" altLang="en-US"/>
+              <a:t>按一下以編輯母片標題樣式</a:t>
+            </a:r>
+          </a:p>
+        </p:txBody>
+      </p:sp>
+      <p:sp>
+        <p:nvSpPr>
+          <p:cNvPr id="3" name="文字版面配置區 2"/>
           <p:cNvSpPr>
             <a:spLocks noGrp="1"/>
           </p:cNvSpPr>
@@ -2524,59 +2660,58 @@
         </p:nvSpPr>
         <p:spPr>
           <a:xfrm>
-            <a:off x="457200" y="1600200"/>
-            <a:ext cx="8229600" cy="4709160"/>
+            <a:off x="609600" y="1600203"/>
+            <a:ext cx="10972800" cy="4525963"/>
           </a:xfrm>
           <a:prstGeom prst="rect">
             <a:avLst/>
           </a:prstGeom>
         </p:spPr>
         <p:txBody>
-          <a:bodyPr vert="horz">
+          <a:bodyPr vert="horz" lIns="91440" tIns="45720" rIns="91440" bIns="45720" rtlCol="0">
             <a:normAutofit/>
           </a:bodyPr>
           <a:lstStyle/>
           <a:p>
-            <a:pPr lvl="0" eaLnBrk="1" latinLnBrk="0" hangingPunct="1"/>
-            <a:r>
-              <a:rPr kumimoji="0" lang="en-US" smtClean="0"/>
-              <a:t>Click to edit Master text styles</a:t>
-            </a:r>
-          </a:p>
-          <a:p>
-            <a:pPr lvl="1" eaLnBrk="1" latinLnBrk="0" hangingPunct="1"/>
-            <a:r>
-              <a:rPr kumimoji="0" lang="en-US" smtClean="0"/>
-              <a:t>Second level</a:t>
-            </a:r>
-          </a:p>
-          <a:p>
-            <a:pPr lvl="2" eaLnBrk="1" latinLnBrk="0" hangingPunct="1"/>
-            <a:r>
-              <a:rPr kumimoji="0" lang="en-US" smtClean="0"/>
-              <a:t>Third level</a:t>
-            </a:r>
-          </a:p>
-          <a:p>
-            <a:pPr lvl="3" eaLnBrk="1" latinLnBrk="0" hangingPunct="1"/>
-            <a:r>
-              <a:rPr kumimoji="0" lang="en-US" smtClean="0"/>
-              <a:t>Fourth level</a:t>
-            </a:r>
-          </a:p>
-          <a:p>
-            <a:pPr lvl="4" eaLnBrk="1" latinLnBrk="0" hangingPunct="1"/>
-            <a:r>
-              <a:rPr kumimoji="0" lang="en-US" smtClean="0"/>
-              <a:t>Fifth level</a:t>
-            </a:r>
-            <a:endParaRPr kumimoji="0" lang="en-US"/>
-          </a:p>
-        </p:txBody>
-      </p:sp>
-      <p:sp>
-        <p:nvSpPr>
-          <p:cNvPr id="14" name="Date Placeholder 13"/>
+            <a:pPr lvl="0"/>
+            <a:r>
+              <a:rPr lang="zh-TW" altLang="en-US"/>
+              <a:t>按一下以編輯母片文字樣式</a:t>
+            </a:r>
+          </a:p>
+          <a:p>
+            <a:pPr lvl="1"/>
+            <a:r>
+              <a:rPr lang="zh-TW" altLang="en-US"/>
+              <a:t>第二層</a:t>
+            </a:r>
+          </a:p>
+          <a:p>
+            <a:pPr lvl="2"/>
+            <a:r>
+              <a:rPr lang="zh-TW" altLang="en-US"/>
+              <a:t>第三層</a:t>
+            </a:r>
+          </a:p>
+          <a:p>
+            <a:pPr lvl="3"/>
+            <a:r>
+              <a:rPr lang="zh-TW" altLang="en-US"/>
+              <a:t>第四層</a:t>
+            </a:r>
+          </a:p>
+          <a:p>
+            <a:pPr lvl="4"/>
+            <a:r>
+              <a:rPr lang="zh-TW" altLang="en-US"/>
+              <a:t>第五層</a:t>
+            </a:r>
+          </a:p>
+        </p:txBody>
+      </p:sp>
+      <p:sp>
+        <p:nvSpPr>
+          <p:cNvPr id="4" name="日期版面配置區 3"/>
           <p:cNvSpPr>
             <a:spLocks noGrp="1"/>
           </p:cNvSpPr>
@@ -2586,21 +2721,21 @@
         </p:nvSpPr>
         <p:spPr>
           <a:xfrm>
-            <a:off x="457200" y="6416675"/>
-            <a:ext cx="2133600" cy="365125"/>
+            <a:off x="609600" y="6356354"/>
+            <a:ext cx="2844800" cy="365125"/>
           </a:xfrm>
           <a:prstGeom prst="rect">
             <a:avLst/>
           </a:prstGeom>
         </p:spPr>
         <p:txBody>
-          <a:bodyPr vert="horz" anchor="b"/>
+          <a:bodyPr vert="horz" lIns="91440" tIns="45720" rIns="91440" bIns="45720" rtlCol="0" anchor="ctr"/>
           <a:lstStyle>
-            <a:lvl1pPr algn="l" eaLnBrk="1" latinLnBrk="0" hangingPunct="1">
-              <a:defRPr kumimoji="0" sz="1200">
+            <a:lvl1pPr algn="l">
+              <a:defRPr sz="1200">
                 <a:solidFill>
                   <a:schemeClr val="tx1">
-                    <a:shade val="50000"/>
+                    <a:tint val="75000"/>
                   </a:schemeClr>
                 </a:solidFill>
               </a:defRPr>
@@ -2609,7 +2744,7 @@
           <a:p>
             <a:fld id="{E43ECC0B-00A7-4233-BD1F-1580B09B8357}" type="datetimeFigureOut">
               <a:rPr lang="en-US" smtClean="0"/>
-              <a:t>2/16/2013</a:t>
+              <a:t>6/30/2025</a:t>
             </a:fld>
             <a:endParaRPr lang="en-US"/>
           </a:p>
@@ -2617,7 +2752,7 @@
       </p:sp>
       <p:sp>
         <p:nvSpPr>
-          <p:cNvPr id="3" name="Footer Placeholder 2"/>
+          <p:cNvPr id="5" name="頁尾版面配置區 4"/>
           <p:cNvSpPr>
             <a:spLocks noGrp="1"/>
           </p:cNvSpPr>
@@ -2627,21 +2762,21 @@
         </p:nvSpPr>
         <p:spPr>
           <a:xfrm>
-            <a:off x="3124200" y="6416675"/>
-            <a:ext cx="2895600" cy="365125"/>
+            <a:off x="4165600" y="6356354"/>
+            <a:ext cx="3860800" cy="365125"/>
           </a:xfrm>
           <a:prstGeom prst="rect">
             <a:avLst/>
           </a:prstGeom>
         </p:spPr>
         <p:txBody>
-          <a:bodyPr vert="horz" anchor="b"/>
+          <a:bodyPr vert="horz" lIns="91440" tIns="45720" rIns="91440" bIns="45720" rtlCol="0" anchor="ctr"/>
           <a:lstStyle>
-            <a:lvl1pPr algn="ctr" eaLnBrk="1" latinLnBrk="0" hangingPunct="1">
-              <a:defRPr kumimoji="0" sz="1200">
+            <a:lvl1pPr algn="ctr">
+              <a:defRPr sz="1200">
                 <a:solidFill>
                   <a:schemeClr val="tx1">
-                    <a:shade val="50000"/>
+                    <a:tint val="75000"/>
                   </a:schemeClr>
                 </a:solidFill>
               </a:defRPr>
@@ -2654,7 +2789,7 @@
       </p:sp>
       <p:sp>
         <p:nvSpPr>
-          <p:cNvPr id="23" name="Slide Number Placeholder 22"/>
+          <p:cNvPr id="6" name="投影片編號版面配置區 5"/>
           <p:cNvSpPr>
             <a:spLocks noGrp="1"/>
           </p:cNvSpPr>
@@ -2664,21 +2799,21 @@
         </p:nvSpPr>
         <p:spPr>
           <a:xfrm>
-            <a:off x="7924800" y="6416675"/>
-            <a:ext cx="762000" cy="365125"/>
+            <a:off x="8737600" y="6356354"/>
+            <a:ext cx="2844800" cy="365125"/>
           </a:xfrm>
           <a:prstGeom prst="rect">
             <a:avLst/>
           </a:prstGeom>
         </p:spPr>
         <p:txBody>
-          <a:bodyPr vert="horz" lIns="0" rIns="0" anchor="b"/>
+          <a:bodyPr vert="horz" lIns="91440" tIns="45720" rIns="91440" bIns="45720" rtlCol="0" anchor="ctr"/>
           <a:lstStyle>
-            <a:lvl1pPr algn="r" eaLnBrk="1" latinLnBrk="0" hangingPunct="1">
-              <a:defRPr kumimoji="0" sz="1200">
+            <a:lvl1pPr algn="r">
+              <a:defRPr sz="1200">
                 <a:solidFill>
                   <a:schemeClr val="tx1">
-                    <a:shade val="50000"/>
+                    <a:tint val="75000"/>
                   </a:schemeClr>
                 </a:solidFill>
               </a:defRPr>
@@ -2694,62 +2829,37 @@
         </p:txBody>
       </p:sp>
     </p:spTree>
+    <p:extLst>
+      <p:ext uri="{BB962C8B-B14F-4D97-AF65-F5344CB8AC3E}">
+        <p14:creationId xmlns:p14="http://schemas.microsoft.com/office/powerpoint/2010/main" val="1717123183"/>
+      </p:ext>
+    </p:extLst>
   </p:cSld>
-  <p:clrMap bg1="dk1" tx1="lt1" bg2="dk2" tx2="lt2" accent1="accent1" accent2="accent2" accent3="accent3" accent4="accent4" accent5="accent5" accent6="accent6" hlink="hlink" folHlink="folHlink"/>
+  <p:clrMap bg1="lt1" tx1="dk1" bg2="lt2" tx2="dk2" accent1="accent1" accent2="accent2" accent3="accent3" accent4="accent4" accent5="accent5" accent6="accent6" hlink="hlink" folHlink="folHlink"/>
   <p:sldLayoutIdLst>
-    <p:sldLayoutId id="2147483661" r:id="rId1"/>
-    <p:sldLayoutId id="2147483662" r:id="rId2"/>
-    <p:sldLayoutId id="2147483663" r:id="rId3"/>
-    <p:sldLayoutId id="2147483664" r:id="rId4"/>
-    <p:sldLayoutId id="2147483665" r:id="rId5"/>
-    <p:sldLayoutId id="2147483666" r:id="rId6"/>
-    <p:sldLayoutId id="2147483667" r:id="rId7"/>
-    <p:sldLayoutId id="2147483668" r:id="rId8"/>
-    <p:sldLayoutId id="2147483669" r:id="rId9"/>
-    <p:sldLayoutId id="2147483670" r:id="rId10"/>
-    <p:sldLayoutId id="2147483671" r:id="rId11"/>
+    <p:sldLayoutId id="2147483673" r:id="rId1"/>
+    <p:sldLayoutId id="2147483674" r:id="rId2"/>
+    <p:sldLayoutId id="2147483675" r:id="rId3"/>
+    <p:sldLayoutId id="2147483676" r:id="rId4"/>
+    <p:sldLayoutId id="2147483677" r:id="rId5"/>
+    <p:sldLayoutId id="2147483678" r:id="rId6"/>
+    <p:sldLayoutId id="2147483679" r:id="rId7"/>
+    <p:sldLayoutId id="2147483680" r:id="rId8"/>
+    <p:sldLayoutId id="2147483681" r:id="rId9"/>
+    <p:sldLayoutId id="2147483682" r:id="rId10"/>
+    <p:sldLayoutId id="2147483683" r:id="rId11"/>
   </p:sldLayoutIdLst>
   <p:txStyles>
     <p:titleStyle>
-      <a:lvl1pPr algn="ctr" rtl="0" eaLnBrk="1" latinLnBrk="0" hangingPunct="1">
+      <a:lvl1pPr algn="ctr" defTabSz="914378" rtl="0" eaLnBrk="1" latinLnBrk="0" hangingPunct="1">
         <a:spcBef>
           <a:spcPct val="0"/>
         </a:spcBef>
         <a:buNone/>
-        <a:defRPr kumimoji="0" sz="4100" b="1" kern="1200" cap="none" baseline="0">
-          <a:ln w="6350">
-            <a:noFill/>
-          </a:ln>
-          <a:gradFill>
-            <a:gsLst>
-              <a:gs pos="0">
-                <a:schemeClr val="accent1">
-                  <a:tint val="73000"/>
-                  <a:satMod val="145000"/>
-                </a:schemeClr>
-              </a:gs>
-              <a:gs pos="73000">
-                <a:schemeClr val="accent1">
-                  <a:tint val="73000"/>
-                  <a:satMod val="145000"/>
-                </a:schemeClr>
-              </a:gs>
-              <a:gs pos="100000">
-                <a:schemeClr val="accent1">
-                  <a:tint val="83000"/>
-                  <a:satMod val="143000"/>
-                </a:schemeClr>
-              </a:gs>
-            </a:gsLst>
-            <a:lin ang="4800000" scaled="1"/>
-          </a:gradFill>
-          <a:effectLst>
-            <a:outerShdw blurRad="114300" dist="101600" dir="2700000" algn="tl" rotWithShape="0">
-              <a:srgbClr val="000000">
-                <a:alpha val="40000"/>
-              </a:srgbClr>
-            </a:outerShdw>
-          </a:effectLst>
+        <a:defRPr sz="4400" kern="1200">
+          <a:solidFill>
+            <a:schemeClr val="tx1"/>
+          </a:solidFill>
           <a:latin typeface="+mj-lt"/>
           <a:ea typeface="+mj-ea"/>
           <a:cs typeface="+mj-cs"/>
@@ -2757,19 +2867,13 @@
       </a:lvl1pPr>
     </p:titleStyle>
     <p:bodyStyle>
-      <a:lvl1pPr marL="548640" indent="-411480" algn="l" rtl="0" eaLnBrk="1" latinLnBrk="0" hangingPunct="1">
+      <a:lvl1pPr marL="342892" indent="-342892" algn="l" defTabSz="914378" rtl="0" eaLnBrk="1" latinLnBrk="0" hangingPunct="1">
         <a:spcBef>
           <a:spcPct val="20000"/>
         </a:spcBef>
-        <a:buClr>
-          <a:schemeClr val="tx1">
-            <a:shade val="95000"/>
-          </a:schemeClr>
-        </a:buClr>
-        <a:buSzPct val="65000"/>
-        <a:buFont typeface="Wingdings 2"/>
-        <a:buChar char=""/>
-        <a:defRPr kumimoji="0" sz="2800" kern="1200">
+        <a:buFont typeface="Arial" panose="02080604020202020204" pitchFamily="34" charset="0"/>
+        <a:buChar char="•"/>
+        <a:defRPr sz="3200" kern="1200">
           <a:solidFill>
             <a:schemeClr val="tx1"/>
           </a:solidFill>
@@ -2778,17 +2882,13 @@
           <a:cs typeface="+mn-cs"/>
         </a:defRPr>
       </a:lvl1pPr>
-      <a:lvl2pPr marL="868680" indent="-283464" algn="l" rtl="0" eaLnBrk="1" latinLnBrk="0" hangingPunct="1">
+      <a:lvl2pPr marL="742931" indent="-285743" algn="l" defTabSz="914378" rtl="0" eaLnBrk="1" latinLnBrk="0" hangingPunct="1">
         <a:spcBef>
           <a:spcPct val="20000"/>
         </a:spcBef>
-        <a:buClr>
-          <a:schemeClr val="tx1"/>
-        </a:buClr>
-        <a:buSzPct val="80000"/>
-        <a:buFont typeface="Wingdings 2"/>
-        <a:buChar char=""/>
-        <a:defRPr kumimoji="0" sz="2400" kern="1200">
+        <a:buFont typeface="Arial" panose="02080604020202020204" pitchFamily="34" charset="0"/>
+        <a:buChar char="–"/>
+        <a:defRPr sz="2800" kern="1200">
           <a:solidFill>
             <a:schemeClr val="tx1"/>
           </a:solidFill>
@@ -2797,17 +2897,13 @@
           <a:cs typeface="+mn-cs"/>
         </a:defRPr>
       </a:lvl2pPr>
-      <a:lvl3pPr marL="1133856" indent="-228600" algn="l" rtl="0" eaLnBrk="1" latinLnBrk="0" hangingPunct="1">
+      <a:lvl3pPr marL="1142972" indent="-228594" algn="l" defTabSz="914378" rtl="0" eaLnBrk="1" latinLnBrk="0" hangingPunct="1">
         <a:spcBef>
           <a:spcPct val="20000"/>
         </a:spcBef>
-        <a:buClr>
-          <a:schemeClr val="tx1"/>
-        </a:buClr>
-        <a:buSzPct val="95000"/>
-        <a:buFont typeface="Wingdings"/>
-        <a:buChar char=""/>
-        <a:defRPr kumimoji="0" sz="2200" kern="1200">
+        <a:buFont typeface="Arial" panose="02080604020202020204" pitchFamily="34" charset="0"/>
+        <a:buChar char="•"/>
+        <a:defRPr sz="2400" kern="1200">
           <a:solidFill>
             <a:schemeClr val="tx1"/>
           </a:solidFill>
@@ -2816,17 +2912,13 @@
           <a:cs typeface="+mn-cs"/>
         </a:defRPr>
       </a:lvl3pPr>
-      <a:lvl4pPr marL="1353312" indent="-182880" algn="l" rtl="0" eaLnBrk="1" latinLnBrk="0" hangingPunct="1">
+      <a:lvl4pPr marL="1600160" indent="-228594" algn="l" defTabSz="914378" rtl="0" eaLnBrk="1" latinLnBrk="0" hangingPunct="1">
         <a:spcBef>
           <a:spcPct val="20000"/>
         </a:spcBef>
-        <a:buClr>
-          <a:schemeClr val="tx1"/>
-        </a:buClr>
-        <a:buSzPct val="100000"/>
-        <a:buFont typeface="Wingdings 3"/>
-        <a:buChar char=""/>
-        <a:defRPr kumimoji="0" sz="2000" kern="1200">
+        <a:buFont typeface="Arial" panose="02080604020202020204" pitchFamily="34" charset="0"/>
+        <a:buChar char="–"/>
+        <a:defRPr sz="2000" kern="1200">
           <a:solidFill>
             <a:schemeClr val="tx1"/>
           </a:solidFill>
@@ -2835,16 +2927,13 @@
           <a:cs typeface="+mn-cs"/>
         </a:defRPr>
       </a:lvl4pPr>
-      <a:lvl5pPr marL="1545336" indent="-182880" algn="l" rtl="0" eaLnBrk="1" latinLnBrk="0" hangingPunct="1">
+      <a:lvl5pPr marL="2057348" indent="-228594" algn="l" defTabSz="914378" rtl="0" eaLnBrk="1" latinLnBrk="0" hangingPunct="1">
         <a:spcBef>
           <a:spcPct val="20000"/>
         </a:spcBef>
-        <a:buClr>
-          <a:schemeClr val="tx1"/>
-        </a:buClr>
-        <a:buFont typeface="Wingdings 2"/>
-        <a:buChar char=""/>
-        <a:defRPr kumimoji="0" sz="2000" kern="1200">
+        <a:buFont typeface="Arial" panose="02080604020202020204" pitchFamily="34" charset="0"/>
+        <a:buChar char="»"/>
+        <a:defRPr sz="2000" kern="1200">
           <a:solidFill>
             <a:schemeClr val="tx1"/>
           </a:solidFill>
@@ -2853,16 +2942,13 @@
           <a:cs typeface="+mn-cs"/>
         </a:defRPr>
       </a:lvl5pPr>
-      <a:lvl6pPr marL="1764792" indent="-182880" algn="l" rtl="0" eaLnBrk="1" latinLnBrk="0" hangingPunct="1">
+      <a:lvl6pPr marL="2514537" indent="-228594" algn="l" defTabSz="914378" rtl="0" eaLnBrk="1" latinLnBrk="0" hangingPunct="1">
         <a:spcBef>
           <a:spcPct val="20000"/>
         </a:spcBef>
-        <a:buClr>
-          <a:schemeClr val="tx1"/>
-        </a:buClr>
-        <a:buFont typeface="Wingdings 3"/>
-        <a:buChar char=""/>
-        <a:defRPr kumimoji="0" sz="1800" kern="1200">
+        <a:buFont typeface="Arial" panose="02080604020202020204" pitchFamily="34" charset="0"/>
+        <a:buChar char="•"/>
+        <a:defRPr sz="2000" kern="1200">
           <a:solidFill>
             <a:schemeClr val="tx1"/>
           </a:solidFill>
@@ -2871,16 +2957,13 @@
           <a:cs typeface="+mn-cs"/>
         </a:defRPr>
       </a:lvl6pPr>
-      <a:lvl7pPr marL="1965960" indent="-182880" algn="l" rtl="0" eaLnBrk="1" latinLnBrk="0" hangingPunct="1">
+      <a:lvl7pPr marL="2971726" indent="-228594" algn="l" defTabSz="914378" rtl="0" eaLnBrk="1" latinLnBrk="0" hangingPunct="1">
         <a:spcBef>
           <a:spcPct val="20000"/>
         </a:spcBef>
-        <a:buClr>
-          <a:schemeClr val="tx1"/>
-        </a:buClr>
-        <a:buFont typeface="Wingdings 2"/>
-        <a:buChar char=""/>
-        <a:defRPr kumimoji="0" sz="1600" kern="1200">
+        <a:buFont typeface="Arial" panose="02080604020202020204" pitchFamily="34" charset="0"/>
+        <a:buChar char="•"/>
+        <a:defRPr sz="2000" kern="1200">
           <a:solidFill>
             <a:schemeClr val="tx1"/>
           </a:solidFill>
@@ -2889,16 +2972,13 @@
           <a:cs typeface="+mn-cs"/>
         </a:defRPr>
       </a:lvl7pPr>
-      <a:lvl8pPr marL="2167128" indent="-182880" algn="l" rtl="0" eaLnBrk="1" latinLnBrk="0" hangingPunct="1">
+      <a:lvl8pPr marL="3428915" indent="-228594" algn="l" defTabSz="914378" rtl="0" eaLnBrk="1" latinLnBrk="0" hangingPunct="1">
         <a:spcBef>
           <a:spcPct val="20000"/>
         </a:spcBef>
-        <a:buClr>
-          <a:schemeClr val="tx1"/>
-        </a:buClr>
-        <a:buFont typeface="Wingdings 2"/>
-        <a:buChar char=""/>
-        <a:defRPr kumimoji="0" sz="1400" kern="1200">
+        <a:buFont typeface="Arial" panose="02080604020202020204" pitchFamily="34" charset="0"/>
+        <a:buChar char="•"/>
+        <a:defRPr sz="2000" kern="1200">
           <a:solidFill>
             <a:schemeClr val="tx1"/>
           </a:solidFill>
@@ -2907,16 +2987,13 @@
           <a:cs typeface="+mn-cs"/>
         </a:defRPr>
       </a:lvl8pPr>
-      <a:lvl9pPr marL="2368296" indent="-182880" algn="l" rtl="0" eaLnBrk="1" latinLnBrk="0" hangingPunct="1">
+      <a:lvl9pPr marL="3886103" indent="-228594" algn="l" defTabSz="914378" rtl="0" eaLnBrk="1" latinLnBrk="0" hangingPunct="1">
         <a:spcBef>
           <a:spcPct val="20000"/>
         </a:spcBef>
-        <a:buClr>
-          <a:schemeClr val="tx1"/>
-        </a:buClr>
-        <a:buFont typeface="Wingdings 2"/>
-        <a:buChar char=""/>
-        <a:defRPr kumimoji="0" sz="1400" kern="1200" baseline="0">
+        <a:buFont typeface="Arial" panose="02080604020202020204" pitchFamily="34" charset="0"/>
+        <a:buChar char="•"/>
+        <a:defRPr sz="2000" kern="1200">
           <a:solidFill>
             <a:schemeClr val="tx1"/>
           </a:solidFill>
@@ -2927,8 +3004,11 @@
       </a:lvl9pPr>
     </p:bodyStyle>
     <p:otherStyle>
-      <a:lvl1pPr marL="0" algn="l" rtl="0" eaLnBrk="1" latinLnBrk="0" hangingPunct="1">
-        <a:defRPr kumimoji="0" kern="1200">
+      <a:defPPr>
+        <a:defRPr lang="zh-TW"/>
+      </a:defPPr>
+      <a:lvl1pPr marL="0" algn="l" defTabSz="914378" rtl="0" eaLnBrk="1" latinLnBrk="0" hangingPunct="1">
+        <a:defRPr sz="1800" kern="1200">
           <a:solidFill>
             <a:schemeClr val="tx1"/>
           </a:solidFill>
@@ -2937,8 +3017,8 @@
           <a:cs typeface="+mn-cs"/>
         </a:defRPr>
       </a:lvl1pPr>
-      <a:lvl2pPr marL="457200" algn="l" rtl="0" eaLnBrk="1" latinLnBrk="0" hangingPunct="1">
-        <a:defRPr kumimoji="0" kern="1200">
+      <a:lvl2pPr marL="457189" algn="l" defTabSz="914378" rtl="0" eaLnBrk="1" latinLnBrk="0" hangingPunct="1">
+        <a:defRPr sz="1800" kern="1200">
           <a:solidFill>
             <a:schemeClr val="tx1"/>
           </a:solidFill>
@@ -2947,8 +3027,8 @@
           <a:cs typeface="+mn-cs"/>
         </a:defRPr>
       </a:lvl2pPr>
-      <a:lvl3pPr marL="914400" algn="l" rtl="0" eaLnBrk="1" latinLnBrk="0" hangingPunct="1">
-        <a:defRPr kumimoji="0" kern="1200">
+      <a:lvl3pPr marL="914378" algn="l" defTabSz="914378" rtl="0" eaLnBrk="1" latinLnBrk="0" hangingPunct="1">
+        <a:defRPr sz="1800" kern="1200">
           <a:solidFill>
             <a:schemeClr val="tx1"/>
           </a:solidFill>
@@ -2957,8 +3037,8 @@
           <a:cs typeface="+mn-cs"/>
         </a:defRPr>
       </a:lvl3pPr>
-      <a:lvl4pPr marL="1371600" algn="l" rtl="0" eaLnBrk="1" latinLnBrk="0" hangingPunct="1">
-        <a:defRPr kumimoji="0" kern="1200">
+      <a:lvl4pPr marL="1371566" algn="l" defTabSz="914378" rtl="0" eaLnBrk="1" latinLnBrk="0" hangingPunct="1">
+        <a:defRPr sz="1800" kern="1200">
           <a:solidFill>
             <a:schemeClr val="tx1"/>
           </a:solidFill>
@@ -2967,8 +3047,8 @@
           <a:cs typeface="+mn-cs"/>
         </a:defRPr>
       </a:lvl4pPr>
-      <a:lvl5pPr marL="1828800" algn="l" rtl="0" eaLnBrk="1" latinLnBrk="0" hangingPunct="1">
-        <a:defRPr kumimoji="0" kern="1200">
+      <a:lvl5pPr marL="1828754" algn="l" defTabSz="914378" rtl="0" eaLnBrk="1" latinLnBrk="0" hangingPunct="1">
+        <a:defRPr sz="1800" kern="1200">
           <a:solidFill>
             <a:schemeClr val="tx1"/>
           </a:solidFill>
@@ -2977,8 +3057,8 @@
           <a:cs typeface="+mn-cs"/>
         </a:defRPr>
       </a:lvl5pPr>
-      <a:lvl6pPr marL="2286000" algn="l" rtl="0" eaLnBrk="1" latinLnBrk="0" hangingPunct="1">
-        <a:defRPr kumimoji="0" kern="1200">
+      <a:lvl6pPr marL="2285943" algn="l" defTabSz="914378" rtl="0" eaLnBrk="1" latinLnBrk="0" hangingPunct="1">
+        <a:defRPr sz="1800" kern="1200">
           <a:solidFill>
             <a:schemeClr val="tx1"/>
           </a:solidFill>
@@ -2987,8 +3067,8 @@
           <a:cs typeface="+mn-cs"/>
         </a:defRPr>
       </a:lvl6pPr>
-      <a:lvl7pPr marL="2743200" algn="l" rtl="0" eaLnBrk="1" latinLnBrk="0" hangingPunct="1">
-        <a:defRPr kumimoji="0" kern="1200">
+      <a:lvl7pPr marL="2743132" algn="l" defTabSz="914378" rtl="0" eaLnBrk="1" latinLnBrk="0" hangingPunct="1">
+        <a:defRPr sz="1800" kern="1200">
           <a:solidFill>
             <a:schemeClr val="tx1"/>
           </a:solidFill>
@@ -2997,8 +3077,8 @@
           <a:cs typeface="+mn-cs"/>
         </a:defRPr>
       </a:lvl7pPr>
-      <a:lvl8pPr marL="3200400" algn="l" rtl="0" eaLnBrk="1" latinLnBrk="0" hangingPunct="1">
-        <a:defRPr kumimoji="0" kern="1200">
+      <a:lvl8pPr marL="3200320" algn="l" defTabSz="914378" rtl="0" eaLnBrk="1" latinLnBrk="0" hangingPunct="1">
+        <a:defRPr sz="1800" kern="1200">
           <a:solidFill>
             <a:schemeClr val="tx1"/>
           </a:solidFill>
@@ -3007,8 +3087,8 @@
           <a:cs typeface="+mn-cs"/>
         </a:defRPr>
       </a:lvl8pPr>
-      <a:lvl9pPr marL="3657600" algn="l" rtl="0" eaLnBrk="1" latinLnBrk="0" hangingPunct="1">
-        <a:defRPr kumimoji="0" kern="1200">
+      <a:lvl9pPr marL="3657509" algn="l" defTabSz="914378" rtl="0" eaLnBrk="1" latinLnBrk="0" hangingPunct="1">
+        <a:defRPr sz="1800" kern="1200">
           <a:solidFill>
             <a:schemeClr val="tx1"/>
           </a:solidFill>
@@ -3051,80 +3131,104 @@
         </p:nvSpPr>
         <p:spPr/>
         <p:txBody>
-          <a:bodyPr/>
-          <a:lstStyle/>
-          <a:p>
-            <a:r>
-              <a:rPr lang="zh-CN" altLang="en-US" dirty="0" smtClean="0"/>
-              <a:t>凱歌</a:t>
-            </a:r>
-            <a:endParaRPr lang="en-US" dirty="0"/>
-          </a:p>
-        </p:txBody>
-      </p:sp>
-      <p:sp>
-        <p:nvSpPr>
-          <p:cNvPr id="5" name="Content Placeholder 4"/>
-          <p:cNvSpPr>
-            <a:spLocks noGrp="1"/>
-          </p:cNvSpPr>
-          <p:nvPr>
-            <p:ph idx="1"/>
-          </p:nvPr>
-        </p:nvSpPr>
-        <p:spPr/>
-        <p:txBody>
           <a:bodyPr>
             <a:normAutofit/>
           </a:bodyPr>
           <a:lstStyle/>
           <a:p>
+            <a:r>
+              <a:rPr lang="zh-CN" altLang="en-US" sz="5400" b="1" dirty="0">
+                <a:latin typeface="Microsoft JhengHei" panose="020B0604030504040204" pitchFamily="34" charset="-120"/>
+                <a:ea typeface="Microsoft JhengHei" panose="020B0604030504040204" pitchFamily="34" charset="-120"/>
+              </a:rPr>
+              <a:t>凱歌</a:t>
+            </a:r>
+            <a:endParaRPr lang="en-US" sz="5400" b="1" dirty="0">
+              <a:latin typeface="Microsoft JhengHei" panose="020B0604030504040204" pitchFamily="34" charset="-120"/>
+              <a:ea typeface="Microsoft JhengHei" panose="020B0604030504040204" pitchFamily="34" charset="-120"/>
+            </a:endParaRPr>
+          </a:p>
+        </p:txBody>
+      </p:sp>
+      <p:sp>
+        <p:nvSpPr>
+          <p:cNvPr id="5" name="Content Placeholder 4"/>
+          <p:cNvSpPr>
+            <a:spLocks noGrp="1"/>
+          </p:cNvSpPr>
+          <p:nvPr>
+            <p:ph idx="1"/>
+          </p:nvPr>
+        </p:nvSpPr>
+        <p:spPr/>
+        <p:txBody>
+          <a:bodyPr>
+            <a:normAutofit/>
+          </a:bodyPr>
+          <a:lstStyle/>
+          <a:p>
             <a:pPr algn="ctr">
               <a:buNone/>
             </a:pPr>
             <a:r>
-              <a:rPr lang="zh-CN" altLang="en-US" sz="5400" dirty="0" smtClean="0"/>
+              <a:rPr lang="zh-CN" altLang="en-US" sz="6000" b="1" dirty="0">
+                <a:latin typeface="Microsoft JhengHei" panose="020B0604030504040204" pitchFamily="34" charset="-120"/>
+                <a:ea typeface="Microsoft JhengHei" panose="020B0604030504040204" pitchFamily="34" charset="-120"/>
+              </a:rPr>
               <a:t>投靠耶和華勝過依賴人</a:t>
             </a:r>
-            <a:endParaRPr lang="en-US" altLang="zh-CN" sz="5400" dirty="0" smtClean="0"/>
+            <a:endParaRPr lang="en-US" altLang="zh-CN" sz="6000" b="1" dirty="0">
+              <a:latin typeface="Microsoft JhengHei" panose="020B0604030504040204" pitchFamily="34" charset="-120"/>
+              <a:ea typeface="Microsoft JhengHei" panose="020B0604030504040204" pitchFamily="34" charset="-120"/>
+            </a:endParaRPr>
           </a:p>
           <a:p>
             <a:pPr algn="ctr">
               <a:buNone/>
             </a:pPr>
             <a:r>
-              <a:rPr lang="zh-CN" altLang="en-US" sz="5400" dirty="0"/>
-              <a:t>投</a:t>
-            </a:r>
-            <a:r>
-              <a:rPr lang="zh-CN" altLang="en-US" sz="5400" dirty="0" smtClean="0"/>
-              <a:t>靠耶和華勝過依賴王子</a:t>
-            </a:r>
-            <a:endParaRPr lang="en-US" altLang="zh-CN" sz="5400" dirty="0" smtClean="0"/>
+              <a:rPr lang="zh-CN" altLang="en-US" sz="6000" b="1" dirty="0">
+                <a:latin typeface="Microsoft JhengHei" panose="020B0604030504040204" pitchFamily="34" charset="-120"/>
+                <a:ea typeface="Microsoft JhengHei" panose="020B0604030504040204" pitchFamily="34" charset="-120"/>
+              </a:rPr>
+              <a:t>投靠耶和華勝過依賴王子</a:t>
+            </a:r>
+            <a:endParaRPr lang="en-US" altLang="zh-CN" sz="6000" b="1" dirty="0">
+              <a:latin typeface="Microsoft JhengHei" panose="020B0604030504040204" pitchFamily="34" charset="-120"/>
+              <a:ea typeface="Microsoft JhengHei" panose="020B0604030504040204" pitchFamily="34" charset="-120"/>
+            </a:endParaRPr>
           </a:p>
           <a:p>
             <a:pPr algn="ctr">
               <a:buNone/>
             </a:pPr>
             <a:r>
-              <a:rPr lang="zh-CN" altLang="en-US" sz="5400" dirty="0"/>
-              <a:t>我</a:t>
-            </a:r>
-            <a:r>
-              <a:rPr lang="zh-CN" altLang="en-US" sz="5400" dirty="0" smtClean="0"/>
-              <a:t>們的幫助從天而來</a:t>
-            </a:r>
-            <a:endParaRPr lang="en-US" altLang="zh-CN" sz="5400" dirty="0" smtClean="0"/>
+              <a:rPr lang="zh-CN" altLang="en-US" sz="6000" b="1" dirty="0">
+                <a:latin typeface="Microsoft JhengHei" panose="020B0604030504040204" pitchFamily="34" charset="-120"/>
+                <a:ea typeface="Microsoft JhengHei" panose="020B0604030504040204" pitchFamily="34" charset="-120"/>
+              </a:rPr>
+              <a:t>我們的幫助從天而來</a:t>
+            </a:r>
+            <a:endParaRPr lang="en-US" altLang="zh-CN" sz="6000" b="1" dirty="0">
+              <a:latin typeface="Microsoft JhengHei" panose="020B0604030504040204" pitchFamily="34" charset="-120"/>
+              <a:ea typeface="Microsoft JhengHei" panose="020B0604030504040204" pitchFamily="34" charset="-120"/>
+            </a:endParaRPr>
           </a:p>
           <a:p>
             <a:pPr algn="ctr">
               <a:buNone/>
             </a:pPr>
             <a:r>
-              <a:rPr lang="zh-CN" altLang="en-US" sz="5400" dirty="0" smtClean="0"/>
+              <a:rPr lang="zh-CN" altLang="en-US" sz="6000" b="1" dirty="0">
+                <a:latin typeface="Microsoft JhengHei" panose="020B0604030504040204" pitchFamily="34" charset="-120"/>
+                <a:ea typeface="Microsoft JhengHei" panose="020B0604030504040204" pitchFamily="34" charset="-120"/>
+              </a:rPr>
               <a:t>從造天地的耶和華而來</a:t>
             </a:r>
-            <a:endParaRPr lang="en-US" sz="5400" dirty="0"/>
+            <a:endParaRPr lang="en-US" sz="6000" b="1" dirty="0">
+              <a:latin typeface="Microsoft JhengHei" panose="020B0604030504040204" pitchFamily="34" charset="-120"/>
+              <a:ea typeface="Microsoft JhengHei" panose="020B0604030504040204" pitchFamily="34" charset="-120"/>
+            </a:endParaRPr>
           </a:p>
         </p:txBody>
       </p:sp>
@@ -3169,10 +3273,16 @@
           <a:lstStyle/>
           <a:p>
             <a:r>
-              <a:rPr lang="zh-CN" altLang="en-US" dirty="0" smtClean="0"/>
+              <a:rPr lang="zh-CN" altLang="en-US" sz="5400" b="1" dirty="0">
+                <a:latin typeface="Microsoft JhengHei" panose="020B0604030504040204" pitchFamily="34" charset="-120"/>
+                <a:ea typeface="Microsoft JhengHei" panose="020B0604030504040204" pitchFamily="34" charset="-120"/>
+              </a:rPr>
               <a:t>凱歌</a:t>
             </a:r>
-            <a:endParaRPr lang="en-US" dirty="0"/>
+            <a:endParaRPr lang="en-US" sz="5400" b="1" dirty="0">
+              <a:latin typeface="Microsoft JhengHei" panose="020B0604030504040204" pitchFamily="34" charset="-120"/>
+              <a:ea typeface="Microsoft JhengHei" panose="020B0604030504040204" pitchFamily="34" charset="-120"/>
+            </a:endParaRPr>
           </a:p>
         </p:txBody>
       </p:sp>
@@ -3188,13 +3298,13 @@
         </p:nvSpPr>
         <p:spPr>
           <a:xfrm>
-            <a:off x="457200" y="1600200"/>
+            <a:off x="1981200" y="1600200"/>
             <a:ext cx="8229600" cy="5105400"/>
           </a:xfrm>
         </p:spPr>
         <p:txBody>
           <a:bodyPr>
-            <a:normAutofit/>
+            <a:normAutofit lnSpcReduction="10000"/>
           </a:bodyPr>
           <a:lstStyle/>
           <a:p>
@@ -3202,58 +3312,80 @@
               <a:buNone/>
             </a:pPr>
             <a:r>
-              <a:rPr lang="zh-CN" altLang="en-US" sz="5400" dirty="0" smtClean="0"/>
+              <a:rPr lang="zh-CN" altLang="en-US" sz="6000" b="1" dirty="0">
+                <a:latin typeface="Microsoft JhengHei" panose="020B0604030504040204" pitchFamily="34" charset="-120"/>
+                <a:ea typeface="Microsoft JhengHei" panose="020B0604030504040204" pitchFamily="34" charset="-120"/>
+              </a:rPr>
               <a:t>必蒙恩惠必不羞愧</a:t>
             </a:r>
-            <a:endParaRPr lang="en-US" altLang="zh-CN" sz="5400" dirty="0" smtClean="0"/>
+            <a:endParaRPr lang="en-US" altLang="zh-CN" sz="6000" b="1" dirty="0">
+              <a:latin typeface="Microsoft JhengHei" panose="020B0604030504040204" pitchFamily="34" charset="-120"/>
+              <a:ea typeface="Microsoft JhengHei" panose="020B0604030504040204" pitchFamily="34" charset="-120"/>
+            </a:endParaRPr>
           </a:p>
           <a:p>
             <a:pPr algn="ctr">
               <a:buNone/>
             </a:pPr>
             <a:r>
-              <a:rPr lang="zh-CN" altLang="en-US" sz="5400" dirty="0"/>
-              <a:t>仇</a:t>
-            </a:r>
-            <a:r>
-              <a:rPr lang="zh-CN" altLang="en-US" sz="5400" dirty="0" smtClean="0"/>
-              <a:t>敵雖兇都要後退</a:t>
-            </a:r>
-            <a:endParaRPr lang="en-US" altLang="zh-CN" sz="5400" dirty="0" smtClean="0"/>
+              <a:rPr lang="zh-CN" altLang="en-US" sz="6000" b="1" dirty="0">
+                <a:latin typeface="Microsoft JhengHei" panose="020B0604030504040204" pitchFamily="34" charset="-120"/>
+                <a:ea typeface="Microsoft JhengHei" panose="020B0604030504040204" pitchFamily="34" charset="-120"/>
+              </a:rPr>
+              <a:t>仇敵雖兇都要後退</a:t>
+            </a:r>
+            <a:endParaRPr lang="en-US" altLang="zh-CN" sz="6000" b="1" dirty="0">
+              <a:latin typeface="Microsoft JhengHei" panose="020B0604030504040204" pitchFamily="34" charset="-120"/>
+              <a:ea typeface="Microsoft JhengHei" panose="020B0604030504040204" pitchFamily="34" charset="-120"/>
+            </a:endParaRPr>
           </a:p>
           <a:p>
             <a:pPr algn="ctr">
               <a:buNone/>
             </a:pPr>
             <a:r>
-              <a:rPr lang="zh-CN" altLang="en-US" sz="5400" dirty="0"/>
-              <a:t>投</a:t>
-            </a:r>
-            <a:r>
-              <a:rPr lang="zh-CN" altLang="en-US" sz="5400" dirty="0" smtClean="0"/>
-              <a:t>靠耶和華的人</a:t>
-            </a:r>
-            <a:endParaRPr lang="en-US" altLang="zh-CN" sz="5400" dirty="0" smtClean="0"/>
+              <a:rPr lang="zh-CN" altLang="en-US" sz="6000" b="1" dirty="0">
+                <a:latin typeface="Microsoft JhengHei" panose="020B0604030504040204" pitchFamily="34" charset="-120"/>
+                <a:ea typeface="Microsoft JhengHei" panose="020B0604030504040204" pitchFamily="34" charset="-120"/>
+              </a:rPr>
+              <a:t>投靠耶和華的人</a:t>
+            </a:r>
+            <a:endParaRPr lang="en-US" altLang="zh-CN" sz="6000" b="1" dirty="0">
+              <a:latin typeface="Microsoft JhengHei" panose="020B0604030504040204" pitchFamily="34" charset="-120"/>
+              <a:ea typeface="Microsoft JhengHei" panose="020B0604030504040204" pitchFamily="34" charset="-120"/>
+            </a:endParaRPr>
           </a:p>
           <a:p>
             <a:pPr algn="ctr">
               <a:buNone/>
             </a:pPr>
             <a:r>
-              <a:rPr lang="zh-CN" altLang="en-US" sz="5400" dirty="0" smtClean="0"/>
+              <a:rPr lang="zh-CN" altLang="en-US" sz="6000" b="1" dirty="0">
+                <a:latin typeface="Microsoft JhengHei" panose="020B0604030504040204" pitchFamily="34" charset="-120"/>
+                <a:ea typeface="Microsoft JhengHei" panose="020B0604030504040204" pitchFamily="34" charset="-120"/>
+              </a:rPr>
               <a:t>投靠耶和華的人</a:t>
             </a:r>
-            <a:endParaRPr lang="en-US" altLang="zh-CN" sz="5400" dirty="0" smtClean="0"/>
+            <a:endParaRPr lang="en-US" altLang="zh-CN" sz="6000" b="1" dirty="0">
+              <a:latin typeface="Microsoft JhengHei" panose="020B0604030504040204" pitchFamily="34" charset="-120"/>
+              <a:ea typeface="Microsoft JhengHei" panose="020B0604030504040204" pitchFamily="34" charset="-120"/>
+            </a:endParaRPr>
           </a:p>
           <a:p>
             <a:pPr algn="ctr">
               <a:buNone/>
             </a:pPr>
             <a:r>
-              <a:rPr lang="zh-CN" altLang="en-US" sz="5400" dirty="0" smtClean="0"/>
+              <a:rPr lang="zh-CN" altLang="en-US" sz="6000" b="1" dirty="0">
+                <a:latin typeface="Microsoft JhengHei" panose="020B0604030504040204" pitchFamily="34" charset="-120"/>
+                <a:ea typeface="Microsoft JhengHei" panose="020B0604030504040204" pitchFamily="34" charset="-120"/>
+              </a:rPr>
               <a:t>必蒙恩惠必不羞愧</a:t>
             </a:r>
-            <a:endParaRPr lang="en-US" sz="5400" dirty="0"/>
+            <a:endParaRPr lang="en-US" sz="6000" b="1" dirty="0">
+              <a:latin typeface="Microsoft JhengHei" panose="020B0604030504040204" pitchFamily="34" charset="-120"/>
+              <a:ea typeface="Microsoft JhengHei" panose="020B0604030504040204" pitchFamily="34" charset="-120"/>
+            </a:endParaRPr>
           </a:p>
         </p:txBody>
       </p:sp>
@@ -3266,9 +3398,9 @@
 </file>
 
 <file path=ppt/theme/theme1.xml><?xml version="1.0" encoding="utf-8"?>
-<a:theme xmlns:a="http://schemas.openxmlformats.org/drawingml/2006/main" name="Apex">
+<a:theme xmlns:a="http://schemas.openxmlformats.org/drawingml/2006/main" name="Theme1">
   <a:themeElements>
-    <a:clrScheme name="Apex">
+    <a:clrScheme name="Office">
       <a:dk1>
         <a:sysClr val="windowText" lastClr="000000"/>
       </a:dk1>
@@ -3276,86 +3408,48 @@
         <a:sysClr val="window" lastClr="FFFFFF"/>
       </a:lt1>
       <a:dk2>
-        <a:srgbClr val="69676D"/>
+        <a:srgbClr val="1F497D"/>
       </a:dk2>
       <a:lt2>
-        <a:srgbClr val="C9C2D1"/>
+        <a:srgbClr val="EEECE1"/>
       </a:lt2>
       <a:accent1>
-        <a:srgbClr val="CEB966"/>
+        <a:srgbClr val="4F81BD"/>
       </a:accent1>
       <a:accent2>
-        <a:srgbClr val="9CB084"/>
+        <a:srgbClr val="C0504D"/>
       </a:accent2>
       <a:accent3>
-        <a:srgbClr val="6BB1C9"/>
+        <a:srgbClr val="9BBB59"/>
       </a:accent3>
       <a:accent4>
-        <a:srgbClr val="6585CF"/>
+        <a:srgbClr val="8064A2"/>
       </a:accent4>
       <a:accent5>
-        <a:srgbClr val="7E6BC9"/>
+        <a:srgbClr val="4BACC6"/>
       </a:accent5>
       <a:accent6>
-        <a:srgbClr val="A379BB"/>
+        <a:srgbClr val="F79646"/>
       </a:accent6>
       <a:hlink>
-        <a:srgbClr val="410082"/>
+        <a:srgbClr val="0000FF"/>
       </a:hlink>
       <a:folHlink>
-        <a:srgbClr val="932968"/>
+        <a:srgbClr val="800080"/>
       </a:folHlink>
     </a:clrScheme>
-    <a:fontScheme name="Apex">
+    <a:fontScheme name="Office">
       <a:majorFont>
-        <a:latin typeface="Lucida Sans"/>
+        <a:latin typeface="Calibri"/>
         <a:ea typeface=""/>
         <a:cs typeface=""/>
-        <a:font script="Grek" typeface="Arial"/>
-        <a:font script="Cyrl" typeface="Arial"/>
-        <a:font script="Jpan" typeface="HG丸ｺﾞｼｯｸM-PRO"/>
-        <a:font script="Hang" typeface="휴먼옛체"/>
-        <a:font script="Hans" typeface="黑体"/>
-        <a:font script="Hant" typeface="微軟正黑體"/>
-        <a:font script="Arab" typeface="Tahoma"/>
-        <a:font script="Hebr" typeface="Levenim MT"/>
-        <a:font script="Thai" typeface="FreesiaUPC"/>
-        <a:font script="Ethi" typeface="Nyala"/>
-        <a:font script="Beng" typeface="Vrinda"/>
-        <a:font script="Gujr" typeface="Shruti"/>
-        <a:font script="Khmr" typeface="DaunPenh"/>
-        <a:font script="Knda" typeface="Tunga"/>
-        <a:font script="Guru" typeface="Raavi"/>
-        <a:font script="Cans" typeface="Euphemia"/>
-        <a:font script="Cher" typeface="Plantagenet Cherokee"/>
-        <a:font script="Yiii" typeface="Microsoft Yi Baiti"/>
-        <a:font script="Tibt" typeface="Microsoft Himalaya"/>
-        <a:font script="Thaa" typeface="MV Boli"/>
-        <a:font script="Deva" typeface="Mangal"/>
-        <a:font script="Telu" typeface="Gautami"/>
-        <a:font script="Taml" typeface="Latha"/>
-        <a:font script="Syrc" typeface="Estrangelo Edessa"/>
-        <a:font script="Orya" typeface="Kalinga"/>
-        <a:font script="Mlym" typeface="Kartika"/>
-        <a:font script="Laoo" typeface="DokChampa"/>
-        <a:font script="Sinh" typeface="Iskoola Pota"/>
-        <a:font script="Mong" typeface="Mongolian Baiti"/>
-        <a:font script="Viet" typeface="Tahoma"/>
-        <a:font script="Uigh" typeface="Microsoft Uighur"/>
-      </a:majorFont>
-      <a:minorFont>
-        <a:latin typeface="Book Antiqua"/>
-        <a:ea typeface=""/>
-        <a:cs typeface=""/>
-        <a:font script="Grek" typeface="Times New Roman"/>
-        <a:font script="Cyrl" typeface="Times New Roman"/>
-        <a:font script="Jpan" typeface="HG明朝B"/>
-        <a:font script="Hang" typeface="돋움"/>
+        <a:font script="Jpan" typeface="ＭＳ Ｐゴシック"/>
+        <a:font script="Hang" typeface="맑은 고딕"/>
         <a:font script="Hans" typeface="宋体"/>
         <a:font script="Hant" typeface="新細明體"/>
         <a:font script="Arab" typeface="Times New Roman"/>
-        <a:font script="Hebr" typeface="David"/>
-        <a:font script="Thai" typeface="EucrosiaUPC"/>
+        <a:font script="Hebr" typeface="Times New Roman"/>
+        <a:font script="Thai" typeface="Angsana New"/>
         <a:font script="Ethi" typeface="Nyala"/>
         <a:font script="Beng" typeface="Vrinda"/>
         <a:font script="Gujr" typeface="Shruti"/>
@@ -3378,75 +3472,100 @@
         <a:font script="Mong" typeface="Mongolian Baiti"/>
         <a:font script="Viet" typeface="Times New Roman"/>
         <a:font script="Uigh" typeface="Microsoft Uighur"/>
+      </a:majorFont>
+      <a:minorFont>
+        <a:latin typeface="Calibri"/>
+        <a:ea typeface=""/>
+        <a:cs typeface=""/>
+        <a:font script="Jpan" typeface="ＭＳ Ｐゴシック"/>
+        <a:font script="Hang" typeface="맑은 고딕"/>
+        <a:font script="Hans" typeface="宋体"/>
+        <a:font script="Hant" typeface="新細明體"/>
+        <a:font script="Arab" typeface="Arial"/>
+        <a:font script="Hebr" typeface="Arial"/>
+        <a:font script="Thai" typeface="Cordia New"/>
+        <a:font script="Ethi" typeface="Nyala"/>
+        <a:font script="Beng" typeface="Vrinda"/>
+        <a:font script="Gujr" typeface="Shruti"/>
+        <a:font script="Khmr" typeface="DaunPenh"/>
+        <a:font script="Knda" typeface="Tunga"/>
+        <a:font script="Guru" typeface="Raavi"/>
+        <a:font script="Cans" typeface="Euphemia"/>
+        <a:font script="Cher" typeface="Plantagenet Cherokee"/>
+        <a:font script="Yiii" typeface="Microsoft Yi Baiti"/>
+        <a:font script="Tibt" typeface="Microsoft Himalaya"/>
+        <a:font script="Thaa" typeface="MV Boli"/>
+        <a:font script="Deva" typeface="Mangal"/>
+        <a:font script="Telu" typeface="Gautami"/>
+        <a:font script="Taml" typeface="Latha"/>
+        <a:font script="Syrc" typeface="Estrangelo Edessa"/>
+        <a:font script="Orya" typeface="Kalinga"/>
+        <a:font script="Mlym" typeface="Kartika"/>
+        <a:font script="Laoo" typeface="DokChampa"/>
+        <a:font script="Sinh" typeface="Iskoola Pota"/>
+        <a:font script="Mong" typeface="Mongolian Baiti"/>
+        <a:font script="Viet" typeface="Arial"/>
+        <a:font script="Uigh" typeface="Microsoft Uighur"/>
       </a:minorFont>
     </a:fontScheme>
-    <a:fmtScheme name="Apex">
+    <a:fmtScheme name="Office">
       <a:fillStyleLst>
         <a:solidFill>
           <a:schemeClr val="phClr"/>
         </a:solidFill>
         <a:gradFill rotWithShape="1">
           <a:gsLst>
-            <a:gs pos="20000">
+            <a:gs pos="0">
               <a:schemeClr val="phClr">
-                <a:tint val="9000"/>
+                <a:tint val="50000"/>
+                <a:satMod val="300000"/>
+              </a:schemeClr>
+            </a:gs>
+            <a:gs pos="35000">
+              <a:schemeClr val="phClr">
+                <a:tint val="37000"/>
+                <a:satMod val="300000"/>
               </a:schemeClr>
             </a:gs>
             <a:gs pos="100000">
               <a:schemeClr val="phClr">
-                <a:tint val="70000"/>
-                <a:satMod val="100000"/>
+                <a:tint val="15000"/>
+                <a:satMod val="350000"/>
               </a:schemeClr>
             </a:gs>
           </a:gsLst>
-          <a:path path="circle">
-            <a:fillToRect l="-15000" t="-15000" r="115000" b="115000"/>
-          </a:path>
+          <a:lin ang="16200000" scaled="1"/>
         </a:gradFill>
         <a:gradFill rotWithShape="1">
           <a:gsLst>
             <a:gs pos="0">
               <a:schemeClr val="phClr">
-                <a:shade val="60000"/>
+                <a:shade val="51000"/>
+                <a:satMod val="130000"/>
               </a:schemeClr>
             </a:gs>
-            <a:gs pos="33000">
+            <a:gs pos="80000">
               <a:schemeClr val="phClr">
-                <a:tint val="86500"/>
-              </a:schemeClr>
-            </a:gs>
-            <a:gs pos="46750">
-              <a:schemeClr val="phClr">
-                <a:tint val="71000"/>
-                <a:satMod val="112000"/>
-              </a:schemeClr>
-            </a:gs>
-            <a:gs pos="53000">
-              <a:schemeClr val="phClr">
-                <a:tint val="71000"/>
-                <a:satMod val="112000"/>
-              </a:schemeClr>
-            </a:gs>
-            <a:gs pos="68000">
-              <a:schemeClr val="phClr">
-                <a:tint val="86000"/>
+                <a:shade val="93000"/>
+                <a:satMod val="130000"/>
               </a:schemeClr>
             </a:gs>
             <a:gs pos="100000">
               <a:schemeClr val="phClr">
-                <a:shade val="60000"/>
+                <a:shade val="94000"/>
+                <a:satMod val="135000"/>
               </a:schemeClr>
             </a:gs>
           </a:gsLst>
-          <a:lin ang="8350000" scaled="1"/>
+          <a:lin ang="16200000" scaled="0"/>
         </a:gradFill>
       </a:fillStyleLst>
       <a:lnStyleLst>
         <a:ln w="9525" cap="flat" cmpd="sng" algn="ctr">
           <a:solidFill>
             <a:schemeClr val="phClr">
-              <a:shade val="48000"/>
-              <a:satMod val="110000"/>
+              <a:shade val="95000"/>
+              <a:satMod val="105000"/>
             </a:schemeClr>
           </a:solidFill>
           <a:prstDash val="solid"/>
@@ -3467,7 +3586,16 @@
       <a:effectStyleLst>
         <a:effectStyle>
           <a:effectLst>
-            <a:outerShdw blurRad="130000" dist="101600" dir="2700000" algn="tl" rotWithShape="0">
+            <a:outerShdw blurRad="40000" dist="20000" dir="5400000" rotWithShape="0">
+              <a:srgbClr val="000000">
+                <a:alpha val="38000"/>
+              </a:srgbClr>
+            </a:outerShdw>
+          </a:effectLst>
+        </a:effectStyle>
+        <a:effectStyle>
+          <a:effectLst>
+            <a:outerShdw blurRad="40000" dist="23000" dir="5400000" rotWithShape="0">
               <a:srgbClr val="000000">
                 <a:alpha val="35000"/>
               </a:srgbClr>
@@ -3476,31 +3604,22 @@
         </a:effectStyle>
         <a:effectStyle>
           <a:effectLst>
-            <a:outerShdw blurRad="190500" dist="228600" dir="2700000" sy="90000" rotWithShape="0">
+            <a:outerShdw blurRad="40000" dist="23000" dir="5400000" rotWithShape="0">
               <a:srgbClr val="000000">
-                <a:alpha val="25500"/>
-              </a:srgbClr>
-            </a:outerShdw>
-          </a:effectLst>
-        </a:effectStyle>
-        <a:effectStyle>
-          <a:effectLst>
-            <a:outerShdw blurRad="190500" dist="228600" dir="2700000" sy="90000" rotWithShape="0">
-              <a:srgbClr val="000000">
-                <a:alpha val="25500"/>
+                <a:alpha val="35000"/>
               </a:srgbClr>
             </a:outerShdw>
           </a:effectLst>
           <a:scene3d>
-            <a:camera prst="orthographicFront" fov="0">
+            <a:camera prst="orthographicFront">
               <a:rot lat="0" lon="0" rev="0"/>
             </a:camera>
-            <a:lightRig rig="soft" dir="tl">
-              <a:rot lat="0" lon="0" rev="20100000"/>
+            <a:lightRig rig="threePt" dir="t">
+              <a:rot lat="0" lon="0" rev="1200000"/>
             </a:lightRig>
           </a:scene3d>
           <a:sp3d>
-            <a:bevelT w="50800" h="50800"/>
+            <a:bevelT w="63500" h="25400"/>
           </a:sp3d>
         </a:effectStyle>
       </a:effectStyleLst>
@@ -3512,42 +3631,56 @@
           <a:gsLst>
             <a:gs pos="0">
               <a:schemeClr val="phClr">
-                <a:tint val="50000"/>
-                <a:satMod val="180000"/>
+                <a:tint val="40000"/>
+                <a:satMod val="350000"/>
+              </a:schemeClr>
+            </a:gs>
+            <a:gs pos="40000">
+              <a:schemeClr val="phClr">
+                <a:tint val="45000"/>
+                <a:shade val="99000"/>
+                <a:satMod val="350000"/>
               </a:schemeClr>
             </a:gs>
             <a:gs pos="100000">
               <a:schemeClr val="phClr">
-                <a:shade val="45000"/>
-                <a:satMod val="120000"/>
+                <a:shade val="20000"/>
+                <a:satMod val="255000"/>
               </a:schemeClr>
             </a:gs>
           </a:gsLst>
           <a:path path="circle">
-            <a:fillToRect r="100000" b="100000"/>
+            <a:fillToRect l="50000" t="-80000" r="50000" b="180000"/>
           </a:path>
         </a:gradFill>
-        <a:blipFill>
-          <a:blip xmlns:r="http://schemas.openxmlformats.org/officeDocument/2006/relationships" r:embed="rId1">
-            <a:duotone>
+        <a:gradFill rotWithShape="1">
+          <a:gsLst>
+            <a:gs pos="0">
               <a:schemeClr val="phClr">
-                <a:shade val="3000"/>
-                <a:satMod val="110000"/>
+                <a:tint val="80000"/>
+                <a:satMod val="300000"/>
               </a:schemeClr>
+            </a:gs>
+            <a:gs pos="100000">
               <a:schemeClr val="phClr">
-                <a:tint val="60000"/>
-                <a:satMod val="425000"/>
+                <a:shade val="30000"/>
+                <a:satMod val="200000"/>
               </a:schemeClr>
-            </a:duotone>
-          </a:blip>
-          <a:stretch>
-            <a:fillRect/>
-          </a:stretch>
-        </a:blipFill>
+            </a:gs>
+          </a:gsLst>
+          <a:path path="circle">
+            <a:fillToRect l="50000" t="50000" r="50000" b="50000"/>
+          </a:path>
+        </a:gradFill>
       </a:bgFillStyleLst>
     </a:fmtScheme>
   </a:themeElements>
   <a:objectDefaults/>
   <a:extraClrSchemeLst/>
+  <a:extLst>
+    <a:ext uri="{05A4C25C-085E-4340-85A3-A5531E510DB2}">
+      <thm15:themeFamily xmlns:thm15="http://schemas.microsoft.com/office/thememl/2012/main" name="Theme1" id="{75BBF97F-0525-4D7F-ABA1-4CCFA07F43A2}" vid="{8D3552C7-B8E4-422B-9896-C8F00D815D11}"/>
+    </a:ext>
+  </a:extLst>
 </a:theme>
 </file>
</xml_diff>